<commit_message>
W04 D5: verify pass (rename stills, tentative tag on fallback, half2 diagram)
Rename GIF stills so the audience tag sits at the end of the filename as the verifier
reads it (C2_W04_D05_holdout_slide_first_STUDENT.png and _still_STUDENT.png). Add the
"tentative" status beside each mention of the IITGN faculty block in the fallback deck,
as every STUDENT file must. Add a mermaid flow on the half2 AI-variant slide so the
deck's one-diagram-per-four-body-slides share clears the gate.

verify.py now reports PASS across every check: notebooks, deck markdown, deck pptx and
the writing-style sweep. Four undated-link warnings remain on the generator source code
(the URLs are in generated YAML strings; the facts file carries each one with its
check date beside it); they are warnings, not failures.

Co-Authored-By: Claude Opus 4.7 <noreply@anthropic.com>
Claude-Session: https://claude.ai/code/session_014iKwG5nnVHpcoiaqquENzm
</commit_message>
<xml_diff>
--- a/content/W04/D5/slides/C2_W04_D05_fallback_STUDENT.pptx
+++ b/content/W04/D5/slides/C2_W04_D05_fallback_STUDENT.pptx
@@ -1033,12 +1033,12 @@
           <a:lstStyle/>
           <a:p>
             <a:r>
-              <a:t>LIVE, 2 minutes. The one rule carries into the Saturday paper's part 5. The faculty block, when</a:t>
-            </a:r>
-          </a:p>
-          <a:p>
-            <a:r>
-              <a:t>it runs on another day, picks up autocorrelation and smoothing from here.</a:t>
+              <a:t>LIVE, 2 minutes. The one rule carries into the Saturday paper's part 5. The IITGN block</a:t>
+            </a:r>
+          </a:p>
+          <a:p>
+            <a:r>
+              <a:t>(tentative), when it runs on another day, picks up autocorrelation and smoothing from here.</a:t>
             </a:r>
           </a:p>
           <a:p>
@@ -4677,7 +4677,7 @@
                 </a:solidFill>
                 <a:latin typeface="Calibri"/>
               </a:rPr>
-              <a:t>What runs if the faculty block slips, and in what order?</a:t>
+              <a:t>What runs if the IITGN block (tentative) slips, and in what order?</a:t>
             </a:r>
           </a:p>
         </p:txBody>
@@ -5726,7 +5726,7 @@
       </p:sp>
       <p:pic>
         <p:nvPicPr>
-          <p:cNvPr id="9" name="mermaid diagram" descr="C2_W04_D05_holdout_slide_STUDENT_still.png"/>
+          <p:cNvPr id="9" name="mermaid diagram" descr="C2_W04_D05_holdout_slide_still_STUDENT.png"/>
           <p:cNvPicPr>
             <a:picLocks noChangeAspect="1"/>
           </p:cNvPicPr>

</xml_diff>

<commit_message>
W04 D5 fix pass: half one, half two and fallback decks revised and rebuilt
Co-Authored-By: Claude Opus 5.5 <noreply@anthropic.com>
Claude-Session: https://claude.ai/code/session_01M71s2Aai15Hcww1vRoxjrv
</commit_message>
<xml_diff>
--- a/content/W04/D5/slides/C2_W04_D05_fallback_STUDENT.pptx
+++ b/content/W04/D5/slides/C2_W04_D05_fallback_STUDENT.pptx
@@ -605,7 +605,7 @@
           </a:p>
           <a:p>
             <a:r>
-              <a:t>own error band with nobody watching the band. Transition: Target Canada.</a:t>
+              <a:t>own error bar with nobody watching it. Transition: Target Canada.</a:t>
             </a:r>
           </a:p>
         </p:txBody>
@@ -5123,7 +5123,7 @@
         </p:nvGraphicFramePr>
         <p:xfrm>
           <a:off x="530352" y="1956816"/>
-          <a:ext cx="11130991" cy="2332736"/>
+          <a:ext cx="11130991" cy="2574544"/>
         </p:xfrm>
         <a:graphic>
           <a:graphicData uri="http://schemas.openxmlformats.org/drawingml/2006/table">
@@ -5160,7 +5160,7 @@
                           </a:solidFill>
                           <a:latin typeface="Calibri"/>
                         </a:rPr>
-                        <a:t>Zillow Offers, 2021 (F3, Zillow's Q3 2021 shareholder letter, checked 12 October 2026)</a:t>
+                        <a:t>Zillow Offers, 2021 (Zillow's Q3 2021 shareholder letter, checked 12 October 2026)</a:t>
                       </a:r>
                     </a:p>
                   </a:txBody>
@@ -5217,7 +5217,7 @@
                   </a:tcPr>
                 </a:tc>
               </a:tr>
-              <a:tr h="369824">
+              <a:tr h="611632">
                 <a:tc>
                   <a:txBody>
                     <a:bodyPr/>
@@ -5252,7 +5252,7 @@
                           </a:solidFill>
                           <a:latin typeface="Calibri"/>
                         </a:rPr>
-                        <a:t>Public targets of plus or minus 200 basis points of breakeven unit economics</a:t>
+                        <a:t>Public targets of plus or minus 200 basis points, 2 percent, of breakeven unit economics: what Zillow made or lost on each home it resold was meant to stay near zero</a:t>
                       </a:r>
                     </a:p>
                   </a:txBody>
@@ -5298,7 +5298,7 @@
                           </a:solidFill>
                           <a:latin typeface="Calibri"/>
                         </a:rPr>
-                        <a:t>Unit economics swung about 1,200 basis points from Q2 to an expected minus 500 to minus 700 in Q4 2021</a:t>
+                        <a:t>Unit economics swung about 1,200 basis points, 12 percentage points, from Q2 to an expected minus 500 to minus 700 basis points in Q4 2021</a:t>
                       </a:r>
                     </a:p>
                   </a:txBody>
@@ -5344,7 +5344,7 @@
                           </a:solidFill>
                           <a:latin typeface="Calibri"/>
                         </a:rPr>
-                        <a:t>A write-down of about USD 304 million on inventory; the business wound down, and about 25 percent of the workforce was cut</a:t>
+                        <a:t>A write-down of about USD 304 million: homes in stock marked below what Zillow paid; the business wound down, and about 25 percent of the workforce was cut</a:t>
                       </a:r>
                     </a:p>
                   </a:txBody>
@@ -5680,7 +5680,7 @@
         </p:nvGraphicFramePr>
         <p:xfrm>
           <a:off x="530352" y="1956816"/>
-          <a:ext cx="11130990" cy="1962912"/>
+          <a:ext cx="11130990" cy="2204720"/>
         </p:xfrm>
         <a:graphic>
           <a:graphicData uri="http://schemas.openxmlformats.org/drawingml/2006/table">
@@ -5692,7 +5692,7 @@
                 <a:gridCol w="3290491"/>
                 <a:gridCol w="7840499"/>
               </a:tblGrid>
-              <a:tr h="369824">
+              <a:tr h="611632">
                 <a:tc>
                   <a:txBody>
                     <a:bodyPr/>
@@ -5717,7 +5717,7 @@
                           </a:solidFill>
                           <a:latin typeface="Calibri"/>
                         </a:rPr>
-                        <a:t>Target Canada, 2013 to 2015 (F4, checked 12 October 2026)</a:t>
+                        <a:t>Target Canada, 2013 to 2015 (Target's release of 15 January 2015 and Canadian Business, checked 12 October 2026)</a:t>
                       </a:r>
                     </a:p>
                   </a:txBody>
@@ -6329,7 +6329,7 @@
                           </a:solidFill>
                           <a:latin typeface="Calibri"/>
                         </a:rPr>
-                        <a:t>Score every week against the error band, and stop when it is breached</a:t>
+                        <a:t>Score every week's miss against the error bar, and stop when it is breached</a:t>
                       </a:r>
                     </a:p>
                   </a:txBody>
@@ -6697,7 +6697,7 @@
         <p:spPr>
           <a:xfrm>
             <a:off x="530352" y="1243584"/>
-            <a:ext cx="11130991" cy="234696"/>
+            <a:ext cx="11130991" cy="399796"/>
           </a:xfrm>
           <a:prstGeom prst="rect">
             <a:avLst/>
@@ -6712,13 +6712,13 @@
           <a:p>
             <a:pPr algn="l"/>
             <a:r>
-              <a:rPr sz="1200" b="0" i="0">
+              <a:rPr sz="1100" b="0" i="0">
                 <a:solidFill>
                   <a:srgbClr val="6B6690"/>
                 </a:solidFill>
                 <a:latin typeface="Calibri"/>
               </a:rPr>
-              <a:t>How does a candidate choose between two stakeholders' forecasts, and present the error?</a:t>
+              <a:t>How does a candidate choose between two stakeholders' forecasts and present the error? [D] tags a differentiator, a question that separates strong candidates.</a:t>
             </a:r>
           </a:p>
         </p:txBody>
@@ -13460,7 +13460,7 @@
                 </a:solidFill>
                 <a:latin typeface="Calibri"/>
               </a:rPr>
-              <a:t>Naive, by about thirty times</a:t>
+              <a:t>Naive, by about thirty-five times</a:t>
             </a:r>
           </a:p>
         </p:txBody>

</xml_diff>

<commit_message>
W04 D5: decks, notes and cheat sheet aligned with the interview fixes and the fresh-graduate audit
Co-Authored-By: Claude Opus 5.5 <noreply@anthropic.com>
Claude-Session: https://claude.ai/code/session_01M71s2Aai15Hcww1vRoxjrv
</commit_message>
<xml_diff>
--- a/content/W04/D5/slides/C2_W04_D05_fallback_STUDENT.pptx
+++ b/content/W04/D5/slides/C2_W04_D05_fallback_STUDENT.pptx
@@ -600,12 +600,22 @@
           <a:lstStyle/>
           <a:p>
             <a:r>
-              <a:t>LIVE, 10 minutes. Groups name the Lucknow equivalent: a vendor forecast allowed to run past its</a:t>
-            </a:r>
-          </a:p>
-          <a:p>
-            <a:r>
-              <a:t>own error bar with nobody watching it. Transition: Target Canada.</a:t>
+              <a:t>LIVE, 10 minutes. The guardrail sat on the margin, and the price forecast's error at a six-month</a:t>
+            </a:r>
+          </a:p>
+          <a:p>
+            <a:r>
+              <a:t>horizon was wider than the whole band; Zillow did stop, by winding the business down. Groups name</a:t>
+            </a:r>
+          </a:p>
+          <a:p>
+            <a:r>
+              <a:t>the Lucknow equivalent: a cushion thinner than the forecast's error at the plan's horizon.</a:t>
+            </a:r>
+          </a:p>
+          <a:p>
+            <a:r>
+              <a:t>Transition: Target Canada.</a:t>
             </a:r>
           </a:p>
         </p:txBody>
@@ -5073,7 +5083,7 @@
                 </a:solidFill>
                 <a:latin typeface="Georgia"/>
               </a:rPr>
-              <a:t>Zillow: a forecast broke its own guardrail</a:t>
+              <a:t>Zillow: a forecast's error outran its guardrail</a:t>
             </a:r>
           </a:p>
         </p:txBody>
@@ -5123,7 +5133,7 @@
         </p:nvGraphicFramePr>
         <p:xfrm>
           <a:off x="530352" y="1956816"/>
-          <a:ext cx="11130991" cy="2574544"/>
+          <a:ext cx="11130991" cy="3058160"/>
         </p:xfrm>
         <a:graphic>
           <a:graphicData uri="http://schemas.openxmlformats.org/drawingml/2006/table">
@@ -5252,7 +5262,7 @@
                           </a:solidFill>
                           <a:latin typeface="Calibri"/>
                         </a:rPr>
-                        <a:t>Public targets of plus or minus 200 basis points, 2 percent, of breakeven unit economics: what Zillow made or lost on each home it resold was meant to stay near zero</a:t>
+                        <a:t>Public targets of plus or minus 200 basis points, 2 percentage points, of breakeven unit economics: what Zillow made or lost on each home it resold was meant to stay near zero</a:t>
                       </a:r>
                     </a:p>
                   </a:txBody>
@@ -5263,7 +5273,7 @@
                   </a:tcPr>
                 </a:tc>
               </a:tr>
-              <a:tr h="611632">
+              <a:tr h="1095248">
                 <a:tc>
                   <a:txBody>
                     <a:bodyPr/>
@@ -5298,7 +5308,7 @@
                           </a:solidFill>
                           <a:latin typeface="Calibri"/>
                         </a:rPr>
-                        <a:t>Unit economics swung about 1,200 basis points, 12 percentage points, from Q2 to an expected minus 500 to minus 700 basis points in Q4 2021</a:t>
+                        <a:t>Price forecasts missed in both directions by far more than Zillow had modelled, and unit economics swung about 1,200 basis points, 12 percentage points, from Q2 to an expected minus 500 to minus 700 basis points in Q4 2021; more offers were accepted than planned, and renovation capacity ran short</a:t>
                       </a:r>
                     </a:p>
                   </a:txBody>
@@ -5344,7 +5354,7 @@
                           </a:solidFill>
                           <a:latin typeface="Calibri"/>
                         </a:rPr>
-                        <a:t>A write-down of about USD 304 million: homes in stock marked below what Zillow paid; the business wound down, and about 25 percent of the workforce was cut</a:t>
+                        <a:t>A write-down of about USD 304 million on homes bought above what they would now sell for; Zillow wound the business down and cut about 25 percent of its workforce</a:t>
                       </a:r>
                     </a:p>
                   </a:txBody>
@@ -5680,7 +5690,7 @@
         </p:nvGraphicFramePr>
         <p:xfrm>
           <a:off x="530352" y="1956816"/>
-          <a:ext cx="11130990" cy="2204720"/>
+          <a:ext cx="11130990" cy="2446528"/>
         </p:xfrm>
         <a:graphic>
           <a:graphicData uri="http://schemas.openxmlformats.org/drawingml/2006/table">
@@ -5774,7 +5784,7 @@
                   </a:tcPr>
                 </a:tc>
               </a:tr>
-              <a:tr h="611632">
+              <a:tr h="853440">
                 <a:tc>
                   <a:txBody>
                     <a:bodyPr/>
@@ -5809,7 +5819,7 @@
                           </a:solidFill>
                           <a:latin typeface="Calibri"/>
                         </a:rPr>
-                        <a:t>Its forecasting and replenishment system needed years of history and could not forecast new stores, so buyers used optimistic projections instead</a:t>
+                        <a:t>Its forecasting and replenishment system needed years of sales history the new stores did not have, so buyers used optimistic projections from headquarters, and the item data feeding it was right about 30 percent of the time</a:t>
                       </a:r>
                     </a:p>
                   </a:txBody>
@@ -5855,7 +5865,7 @@
                           </a:solidFill>
                           <a:latin typeface="Calibri"/>
                         </a:rPr>
-                        <a:t>Distribution centres overflowed while shelves sat empty</a:t>
+                        <a:t>Distribution centres overflowed while shelves sat barely stocked</a:t>
                       </a:r>
                     </a:p>
                   </a:txBody>
@@ -6191,7 +6201,7 @@
         </p:nvGraphicFramePr>
         <p:xfrm>
           <a:off x="530352" y="1956816"/>
-          <a:ext cx="11130989" cy="1593088"/>
+          <a:ext cx="11130990" cy="2560320"/>
         </p:xfrm>
         <a:graphic>
           <a:graphicData uri="http://schemas.openxmlformats.org/drawingml/2006/table">
@@ -6200,9 +6210,9 @@
                 <a:tableStyleId>{2D5ABB26-0587-4C30-8999-92F81FD0307C}</a:tableStyleId>
               </a:tblPr>
               <a:tblGrid>
-                <a:gridCol w="3132847"/>
-                <a:gridCol w="3999071"/>
-                <a:gridCol w="3999071"/>
+                <a:gridCol w="3706162"/>
+                <a:gridCol w="3712414"/>
+                <a:gridCol w="3712414"/>
               </a:tblGrid>
               <a:tr h="369824">
                 <a:tc>
@@ -6272,7 +6282,7 @@
                   </a:tcPr>
                 </a:tc>
               </a:tr>
-              <a:tr h="611632">
+              <a:tr h="853440">
                 <a:tc>
                   <a:txBody>
                     <a:bodyPr/>
@@ -6285,7 +6295,7 @@
                           </a:solidFill>
                           <a:latin typeface="Calibri"/>
                         </a:rPr>
-                        <a:t>Zillow: a forecast ran past its own guardrail</a:t>
+                        <a:t>Zillow: a forecast's error wider than its margin guardrail</a:t>
                       </a:r>
                     </a:p>
                   </a:txBody>
@@ -6329,7 +6339,7 @@
                           </a:solidFill>
                           <a:latin typeface="Calibri"/>
                         </a:rPr>
-                        <a:t>Score every week's miss against the error bar, and stop when it is breached</a:t>
+                        <a:t>Size the forecast's miss at the plan's horizon, and compare it with the cushion before booking</a:t>
                       </a:r>
                     </a:p>
                   </a:txBody>
@@ -6340,7 +6350,7 @@
                   </a:tcPr>
                 </a:tc>
               </a:tr>
-              <a:tr h="611632">
+              <a:tr h="1337056">
                 <a:tc>
                   <a:txBody>
                     <a:bodyPr/>
@@ -6397,7 +6407,7 @@
                           </a:solidFill>
                           <a:latin typeface="Calibri"/>
                         </a:rPr>
-                        <a:t>Score it on 2025's festival from data to September 2025 before it books a shift</a:t>
+                        <a:t>Score it on 2025's festival from data to September 2025 before it books a shift; with no history at all, size from the ground up and keep capacity that can stretch</a:t>
                       </a:r>
                     </a:p>
                   </a:txBody>
@@ -6804,7 +6814,7 @@
                           </a:solidFill>
                           <a:latin typeface="Calibri"/>
                         </a:rPr>
-                        <a:t>"I would average the two: 13 percent sits between 4 and 22."</a:t>
+                        <a:t>"I would go with the vendor, trimmed toward finance: plus 13 percent."</a:t>
                       </a:r>
                     </a:p>
                   </a:txBody>
@@ -6872,7 +6882,7 @@
                           </a:solidFill>
                           <a:latin typeface="Calibri"/>
                         </a:rPr>
-                        <a:t>Concedes what is true in each: finance's growth, the vendor's fit</a:t>
+                        <a:t>Concedes what is true in each: finance's growth, the vendor's tilt to the cheap side</a:t>
                       </a:r>
                     </a:p>
                   </a:txBody>
@@ -8258,8 +8268,8 @@
         </p:blipFill>
         <p:spPr>
           <a:xfrm>
-            <a:off x="2032232" y="1664208"/>
-            <a:ext cx="8127229" cy="3491992"/>
+            <a:off x="2353822" y="1664208"/>
+            <a:ext cx="7484050" cy="3215640"/>
           </a:xfrm>
           <a:prstGeom prst="rect">
             <a:avLst/>
@@ -8274,7 +8284,7 @@
         </p:nvSpPr>
         <p:spPr>
           <a:xfrm>
-            <a:off x="530352" y="5192776"/>
+            <a:off x="530352" y="4916424"/>
             <a:ext cx="11130991" cy="316992"/>
           </a:xfrm>
           <a:prstGeom prst="rect">
@@ -8309,8 +8319,8 @@
         </p:nvSpPr>
         <p:spPr>
           <a:xfrm>
-            <a:off x="530352" y="5518912"/>
-            <a:ext cx="11130991" cy="680720"/>
+            <a:off x="530352" y="5242560"/>
+            <a:ext cx="11130991" cy="957072"/>
           </a:xfrm>
           <a:prstGeom prst="rect">
             <a:avLst/>
@@ -8330,7 +8340,7 @@
                 </a:solidFill>
                 <a:latin typeface="Calibri"/>
               </a:rPr>
-              <a:t>The order barely moves; the numbers move a great deal. The four-week test rests on four misses and on one origin week.</a:t>
+              <a:t>Festival-aligned and finance's rule still lead and the house bot stays next, while naive and drift fall below the vendor; every number moves a great deal. The four-week test rests on four misses and on one origin week.</a:t>
             </a:r>
           </a:p>
         </p:txBody>
@@ -10622,7 +10632,7 @@
                 </a:solidFill>
                 <a:latin typeface="Georgia"/>
               </a:rPr>
-              <a:t>A test shorter than the plan judges too little</a:t>
+              <a:t>A test shorter than the horizon judges too little</a:t>
             </a:r>
           </a:p>
         </p:txBody>
@@ -10657,7 +10667,7 @@
                 </a:solidFill>
                 <a:latin typeface="Calibri"/>
               </a:rPr>
-              <a:t>Why must the hidden weeks span at least the eight weeks the plan covers?</a:t>
+              <a:t>Why must the hidden weeks reach at least as far ahead as the plan does, ten weeks?</a:t>
             </a:r>
           </a:p>
         </p:txBody>
@@ -10671,7 +10681,7 @@
         <p:spPr>
           <a:xfrm>
             <a:off x="530352" y="1956816"/>
-            <a:ext cx="3588410" cy="2154428"/>
+            <a:ext cx="3588410" cy="2344420"/>
           </a:xfrm>
           <a:prstGeom prst="roundRect">
             <a:avLst>
@@ -10869,7 +10879,7 @@
         <p:spPr>
           <a:xfrm>
             <a:off x="731519" y="3303524"/>
-            <a:ext cx="3186074" cy="581406"/>
+            <a:ext cx="3186074" cy="763016"/>
           </a:xfrm>
           <a:prstGeom prst="rect">
             <a:avLst/>
@@ -10890,7 +10900,7 @@
                 </a:solidFill>
                 <a:latin typeface="Calibri"/>
               </a:rPr>
-              <a:t>The plan books eight weeks, so the test hides at least eight (FPP3, section 5.8, checked 12 October 2026).</a:t>
+              <a:t>The plan's last week is ten weeks past the data, so the test must reach ten weeks ahead; four cannot (FPP3, section 5.8, checked 12 October 2026).</a:t>
             </a:r>
           </a:p>
         </p:txBody>
@@ -10904,7 +10914,7 @@
         <p:spPr>
           <a:xfrm>
             <a:off x="4301642" y="1956816"/>
-            <a:ext cx="3588410" cy="2154428"/>
+            <a:ext cx="3588410" cy="2344420"/>
           </a:xfrm>
           <a:prstGeom prst="roundRect">
             <a:avLst>
@@ -11131,7 +11141,7 @@
         <p:spPr>
           <a:xfrm>
             <a:off x="8072932" y="1956816"/>
-            <a:ext cx="3588410" cy="2154428"/>
+            <a:ext cx="3588410" cy="2344420"/>
           </a:xfrm>
           <a:prstGeom prst="roundRect">
             <a:avLst>

</xml_diff>

<commit_message>
W04 D5: the fresh interviewer's read answered: structure said first, the copy-of-last-year concession, the volume concession, per-unit AI costs sized to machines, corrected PLOS and Zillow lines, the guesstimate's range; read and dispositions recorded
Co-Authored-By: Claude Opus 5.5 <noreply@anthropic.com>
Claude-Session: https://claude.ai/code/session_01M71s2Aai15Hcww1vRoxjrv
</commit_message>
<xml_diff>
--- a/content/W04/D5/slides/C2_W04_D05_fallback_STUDENT.pptx
+++ b/content/W04/D5/slides/C2_W04_D05_fallback_STUDENT.pptx
@@ -600,12 +600,12 @@
           <a:lstStyle/>
           <a:p>
             <a:r>
-              <a:t>LIVE, 10 minutes. The guardrail sat on the margin, and the price forecast's error at a six-month</a:t>
-            </a:r>
-          </a:p>
-          <a:p>
-            <a:r>
-              <a:t>horizon was wider than the whole band; Zillow did stop, by winding the business down. Groups name</a:t>
+              <a:t>LIVE, 10 minutes. The guardrail sat on the margin, which suggests the price forecast's error three to</a:t>
+            </a:r>
+          </a:p>
+          <a:p>
+            <a:r>
+              <a:t>six months out was wider than the whole band; Zillow did stop, by winding the business down. Groups name</a:t>
             </a:r>
           </a:p>
           <a:p>

</xml_diff>

<commit_message>
W04 D5: the deck opens on the five topics and teaches them as four concept chapters on the chai stall, then the renumbered case
Half one opens on the topic, the week map, the topics slide and the concept map, then the
ticket; chapters 1 to 4 teach the row's five subtopics on the invented stall, and the case
runs as chapters 5 to 7. The plan quantile moves to the fallback hour, labelled beyond the
row. Ten new figures come from the figures script.

Co-Authored-By: Claude Opus 5.5 <noreply@anthropic.com>
Claude-Session: https://claude.ai/code/session_01Ey99XQtchbgeMsPeBDVB4c
</commit_message>
<xml_diff>
--- a/content/W04/D5/slides/C2_W04_D05_fallback_STUDENT.pptx
+++ b/content/W04/D5/slides/C2_W04_D05_fallback_STUDENT.pptx
@@ -19,6 +19,10 @@
     <p:sldId id="267" r:id="rId19"/>
     <p:sldId id="268" r:id="rId20"/>
     <p:sldId id="269" r:id="rId21"/>
+    <p:sldId id="270" r:id="rId22"/>
+    <p:sldId id="271" r:id="rId23"/>
+    <p:sldId id="272" r:id="rId24"/>
+    <p:sldId id="273" r:id="rId25"/>
   </p:sldIdLst>
   <p:sldSz cx="12191695" cy="6858000" type="screen4x3"/>
   <p:notesSz cx="6858000" cy="9144000"/>
@@ -520,7 +524,12 @@
           </a:p>
           <a:p>
             <a:r>
-              <a:t>autocorrelation, smoothing or ARIMA: the faculty session (tentative) owns them. Read the four parts.</a:t>
+              <a:t>autocorrelation, smoothing or ARIMA: the faculty session (tentative) owns them. Read the five parts;</a:t>
+            </a:r>
+          </a:p>
+          <a:p>
+            <a:r>
+              <a:t>part 3 goes beyond the curriculum row's five subtopics, and says so on its first slide.</a:t>
             </a:r>
           </a:p>
           <a:p>
@@ -600,22 +609,17 @@
           <a:lstStyle/>
           <a:p>
             <a:r>
-              <a:t>LIVE, 10 minutes. The guardrail sat on the margin, which suggests the price forecast's error three to</a:t>
-            </a:r>
-          </a:p>
-          <a:p>
-            <a:r>
-              <a:t>six months out was wider than the whole band; Zillow did stop, by winding the business down. Groups name</a:t>
-            </a:r>
-          </a:p>
-          <a:p>
-            <a:r>
-              <a:t>the Lucknow equivalent: a cushion thinner than the forecast's error at the plan's horizon.</a:t>
-            </a:r>
-          </a:p>
-          <a:p>
-            <a:r>
-              <a:t>Transition: Target Canada.</a:t>
+              <a:t>LIVE, 4 minutes. Vote first. The day's plan, 19,760 shifts, books festival-aligned's forecast itself</a:t>
+            </a:r>
+          </a:p>
+          <a:p>
+            <a:r>
+              <a:t>and prices the error bar both ways; this part asks how far a planner should lean. Transition: the</a:t>
+            </a:r>
+          </a:p>
+          <a:p>
+            <a:r>
+              <a:t>answer.</a:t>
             </a:r>
           </a:p>
         </p:txBody>
@@ -685,17 +689,22 @@
           <a:lstStyle/>
           <a:p>
             <a:r>
-              <a:t>LIVE, 10 minutes. The forecasting account is Canadian Business's, through the archived copy the</a:t>
-            </a:r>
-          </a:p>
-          <a:p>
-            <a:r>
-              <a:t>research ledger cites. The Lucknow version: a vendor model with no Lucknow festival in its record.</a:t>
-            </a:r>
-          </a:p>
-          <a:p>
-            <a:r>
-              <a:t>Transition: the two side by side.</a:t>
+              <a:t>LIVE, 6 minutes. Work the 100 weeks on the board first, then read the curve: the average cost of the</a:t>
+            </a:r>
+          </a:p>
+          <a:p>
+            <a:r>
+              <a:t>week of 19 October with each of the thirteen hidden-week misses tried as its demand. The total is</a:t>
+            </a:r>
+          </a:p>
+          <a:p>
+            <a:r>
+              <a:t>lowest between 2 and 3 percent above the forecast. If the late cost rises toward Rs 40, the low point</a:t>
+            </a:r>
+          </a:p>
+          <a:p>
+            <a:r>
+              <a:t>moves right. Explorer: scene F4. Transition: reading the 0.82 off thirteen weeks.</a:t>
             </a:r>
           </a:p>
         </p:txBody>
@@ -765,12 +774,27 @@
           <a:lstStyle/>
           <a:p>
             <a:r>
-              <a:t>LIVE, 10 minutes. Each group writes the check in one line. Transition: part 4, the second</a:t>
-            </a:r>
-          </a:p>
-          <a:p>
-            <a:r>
-              <a:t>transcript.</a:t>
+              <a:t>LIVE, 5 minutes. Point at the 10th and 11th dots. With thirteen weeks the true point could sit</a:t>
+            </a:r>
+          </a:p>
+          <a:p>
+            <a:r>
+              <a:t>anywhere from about 2 to 3 percent, and the curve on S11 is nearly flat there. The cushion is read</a:t>
+            </a:r>
+          </a:p>
+          <a:p>
+            <a:r>
+              <a:t>from the same weeks it is scored on, so every forecast is compared at its own 0.82 point; a rolling</a:t>
+            </a:r>
+          </a:p>
+          <a:p>
+            <a:r>
+              <a:t>origin through 2025's festival would set it on weeks the test never touches. Transition: the plan,</a:t>
+            </a:r>
+          </a:p>
+          <a:p>
+            <a:r>
+              <a:t>raised.</a:t>
             </a:r>
           </a:p>
         </p:txBody>
@@ -840,12 +864,17 @@
           <a:lstStyle/>
           <a:p>
             <a:r>
-              <a:t>LIVE, 15 minutes. Pairs play the planner and one stakeholder, then swap. The full [D] transcript is</a:t>
-            </a:r>
-          </a:p>
-          <a:p>
-            <a:r>
-              <a:t>in `extras/C2_W04_D05_interview_transcripts_STUDENT.md`. Transition: the close.</a:t>
+              <a:t>LIVE, 5 minutes. Walk the first row aloud: 344,448 times 1.026 is 353,404, over 120 and rounded up is</a:t>
+            </a:r>
+          </a:p>
+          <a:p>
+            <a:r>
+              <a:t>2,946 shifts. Each group writes one line: what the 515 extra shifts buy, and what would lower them.</a:t>
+            </a:r>
+          </a:p>
+          <a:p>
+            <a:r>
+              <a:t>Transition: part 4, two real failures.</a:t>
             </a:r>
           </a:p>
         </p:txBody>
@@ -915,6 +944,321 @@
           <a:lstStyle/>
           <a:p>
             <a:r>
+              <a:t>LIVE, 7 minutes. The guardrail sat on the margin, which suggests the price forecast's error three to</a:t>
+            </a:r>
+          </a:p>
+          <a:p>
+            <a:r>
+              <a:t>six months out was wider than the whole band; Zillow did stop, by winding the business down. Groups name</a:t>
+            </a:r>
+          </a:p>
+          <a:p>
+            <a:r>
+              <a:t>the Lucknow equivalent: a cushion thinner than the forecast's error at the plan's horizon.</a:t>
+            </a:r>
+          </a:p>
+          <a:p>
+            <a:r>
+              <a:t>Transition: Target Canada.</a:t>
+            </a:r>
+          </a:p>
+        </p:txBody>
+      </p:sp>
+      <p:sp>
+        <p:nvSpPr>
+          <p:cNvPr id="4" name="Slide Number Placeholder 3"/>
+          <p:cNvSpPr>
+            <a:spLocks noGrp="1"/>
+          </p:cNvSpPr>
+          <p:nvPr>
+            <p:ph type="sldNum" idx="5" sz="quarter"/>
+          </p:nvPr>
+        </p:nvSpPr>
+        <p:spPr/>
+      </p:sp>
+    </p:spTree>
+  </p:cSld>
+  <p:clrMapOvr>
+    <a:masterClrMapping/>
+  </p:clrMapOvr>
+</p:notes>
+</file>
+
+<file path=ppt/notesSlides/notesSlide15.xml><?xml version="1.0" encoding="utf-8"?>
+<p:notes xmlns:a="http://schemas.openxmlformats.org/drawingml/2006/main" xmlns:p="http://schemas.openxmlformats.org/presentationml/2006/main" xmlns:r="http://schemas.openxmlformats.org/officeDocument/2006/relationships">
+  <p:cSld>
+    <p:spTree>
+      <p:nvGrpSpPr>
+        <p:cNvPr id="1" name=""/>
+        <p:cNvGrpSpPr/>
+        <p:nvPr/>
+      </p:nvGrpSpPr>
+      <p:grpSpPr>
+        <a:xfrm>
+          <a:off x="0" y="0"/>
+          <a:ext cx="0" cy="0"/>
+          <a:chOff x="0" y="0"/>
+          <a:chExt cx="0" cy="0"/>
+        </a:xfrm>
+      </p:grpSpPr>
+      <p:sp>
+        <p:nvSpPr>
+          <p:cNvPr id="2" name="Slide Image Placeholder 1"/>
+          <p:cNvSpPr>
+            <a:spLocks noGrp="1"/>
+          </p:cNvSpPr>
+          <p:nvPr>
+            <p:ph type="sldImg" idx="2"/>
+          </p:nvPr>
+        </p:nvSpPr>
+        <p:spPr/>
+      </p:sp>
+      <p:sp>
+        <p:nvSpPr>
+          <p:cNvPr id="3" name="Notes Placeholder 2"/>
+          <p:cNvSpPr>
+            <a:spLocks noGrp="1"/>
+          </p:cNvSpPr>
+          <p:nvPr>
+            <p:ph type="body" idx="3" sz="quarter"/>
+          </p:nvPr>
+        </p:nvSpPr>
+        <p:spPr/>
+        <p:txBody>
+          <a:bodyPr/>
+          <a:lstStyle/>
+          <a:p>
+            <a:r>
+              <a:t>LIVE, 7 minutes. The forecasting account is Canadian Business's, through the archived copy the</a:t>
+            </a:r>
+          </a:p>
+          <a:p>
+            <a:r>
+              <a:t>research ledger cites. The Lucknow version: a vendor model with no Lucknow festival in its record.</a:t>
+            </a:r>
+          </a:p>
+          <a:p>
+            <a:r>
+              <a:t>Transition: the two side by side.</a:t>
+            </a:r>
+          </a:p>
+        </p:txBody>
+      </p:sp>
+      <p:sp>
+        <p:nvSpPr>
+          <p:cNvPr id="4" name="Slide Number Placeholder 3"/>
+          <p:cNvSpPr>
+            <a:spLocks noGrp="1"/>
+          </p:cNvSpPr>
+          <p:nvPr>
+            <p:ph type="sldNum" idx="5" sz="quarter"/>
+          </p:nvPr>
+        </p:nvSpPr>
+        <p:spPr/>
+      </p:sp>
+    </p:spTree>
+  </p:cSld>
+  <p:clrMapOvr>
+    <a:masterClrMapping/>
+  </p:clrMapOvr>
+</p:notes>
+</file>
+
+<file path=ppt/notesSlides/notesSlide16.xml><?xml version="1.0" encoding="utf-8"?>
+<p:notes xmlns:a="http://schemas.openxmlformats.org/drawingml/2006/main" xmlns:p="http://schemas.openxmlformats.org/presentationml/2006/main" xmlns:r="http://schemas.openxmlformats.org/officeDocument/2006/relationships">
+  <p:cSld>
+    <p:spTree>
+      <p:nvGrpSpPr>
+        <p:cNvPr id="1" name=""/>
+        <p:cNvGrpSpPr/>
+        <p:nvPr/>
+      </p:nvGrpSpPr>
+      <p:grpSpPr>
+        <a:xfrm>
+          <a:off x="0" y="0"/>
+          <a:ext cx="0" cy="0"/>
+          <a:chOff x="0" y="0"/>
+          <a:chExt cx="0" cy="0"/>
+        </a:xfrm>
+      </p:grpSpPr>
+      <p:sp>
+        <p:nvSpPr>
+          <p:cNvPr id="2" name="Slide Image Placeholder 1"/>
+          <p:cNvSpPr>
+            <a:spLocks noGrp="1"/>
+          </p:cNvSpPr>
+          <p:nvPr>
+            <p:ph type="sldImg" idx="2"/>
+          </p:nvPr>
+        </p:nvSpPr>
+        <p:spPr/>
+      </p:sp>
+      <p:sp>
+        <p:nvSpPr>
+          <p:cNvPr id="3" name="Notes Placeholder 2"/>
+          <p:cNvSpPr>
+            <a:spLocks noGrp="1"/>
+          </p:cNvSpPr>
+          <p:nvPr>
+            <p:ph type="body" idx="3" sz="quarter"/>
+          </p:nvPr>
+        </p:nvSpPr>
+        <p:spPr/>
+        <p:txBody>
+          <a:bodyPr/>
+          <a:lstStyle/>
+          <a:p>
+            <a:r>
+              <a:t>LIVE, 6 minutes. Each group writes the check in one line. Transition: part 5, the second</a:t>
+            </a:r>
+          </a:p>
+          <a:p>
+            <a:r>
+              <a:t>transcript.</a:t>
+            </a:r>
+          </a:p>
+        </p:txBody>
+      </p:sp>
+      <p:sp>
+        <p:nvSpPr>
+          <p:cNvPr id="4" name="Slide Number Placeholder 3"/>
+          <p:cNvSpPr>
+            <a:spLocks noGrp="1"/>
+          </p:cNvSpPr>
+          <p:nvPr>
+            <p:ph type="sldNum" idx="5" sz="quarter"/>
+          </p:nvPr>
+        </p:nvSpPr>
+        <p:spPr/>
+      </p:sp>
+    </p:spTree>
+  </p:cSld>
+  <p:clrMapOvr>
+    <a:masterClrMapping/>
+  </p:clrMapOvr>
+</p:notes>
+</file>
+
+<file path=ppt/notesSlides/notesSlide17.xml><?xml version="1.0" encoding="utf-8"?>
+<p:notes xmlns:a="http://schemas.openxmlformats.org/drawingml/2006/main" xmlns:p="http://schemas.openxmlformats.org/presentationml/2006/main" xmlns:r="http://schemas.openxmlformats.org/officeDocument/2006/relationships">
+  <p:cSld>
+    <p:spTree>
+      <p:nvGrpSpPr>
+        <p:cNvPr id="1" name=""/>
+        <p:cNvGrpSpPr/>
+        <p:nvPr/>
+      </p:nvGrpSpPr>
+      <p:grpSpPr>
+        <a:xfrm>
+          <a:off x="0" y="0"/>
+          <a:ext cx="0" cy="0"/>
+          <a:chOff x="0" y="0"/>
+          <a:chExt cx="0" cy="0"/>
+        </a:xfrm>
+      </p:grpSpPr>
+      <p:sp>
+        <p:nvSpPr>
+          <p:cNvPr id="2" name="Slide Image Placeholder 1"/>
+          <p:cNvSpPr>
+            <a:spLocks noGrp="1"/>
+          </p:cNvSpPr>
+          <p:nvPr>
+            <p:ph type="sldImg" idx="2"/>
+          </p:nvPr>
+        </p:nvSpPr>
+        <p:spPr/>
+      </p:sp>
+      <p:sp>
+        <p:nvSpPr>
+          <p:cNvPr id="3" name="Notes Placeholder 2"/>
+          <p:cNvSpPr>
+            <a:spLocks noGrp="1"/>
+          </p:cNvSpPr>
+          <p:nvPr>
+            <p:ph type="body" idx="3" sz="quarter"/>
+          </p:nvPr>
+        </p:nvSpPr>
+        <p:spPr/>
+        <p:txBody>
+          <a:bodyPr/>
+          <a:lstStyle/>
+          <a:p>
+            <a:r>
+              <a:t>LIVE, 23 minutes. Pairs play the planner and one stakeholder, then swap. The full [D] transcript is</a:t>
+            </a:r>
+          </a:p>
+          <a:p>
+            <a:r>
+              <a:t>in `extras/C2_W04_D05_interview_transcripts_STUDENT.md`. Transition: the close.</a:t>
+            </a:r>
+          </a:p>
+        </p:txBody>
+      </p:sp>
+      <p:sp>
+        <p:nvSpPr>
+          <p:cNvPr id="4" name="Slide Number Placeholder 3"/>
+          <p:cNvSpPr>
+            <a:spLocks noGrp="1"/>
+          </p:cNvSpPr>
+          <p:nvPr>
+            <p:ph type="sldNum" idx="5" sz="quarter"/>
+          </p:nvPr>
+        </p:nvSpPr>
+        <p:spPr/>
+      </p:sp>
+    </p:spTree>
+  </p:cSld>
+  <p:clrMapOvr>
+    <a:masterClrMapping/>
+  </p:clrMapOvr>
+</p:notes>
+</file>
+
+<file path=ppt/notesSlides/notesSlide18.xml><?xml version="1.0" encoding="utf-8"?>
+<p:notes xmlns:a="http://schemas.openxmlformats.org/drawingml/2006/main" xmlns:p="http://schemas.openxmlformats.org/presentationml/2006/main" xmlns:r="http://schemas.openxmlformats.org/officeDocument/2006/relationships">
+  <p:cSld>
+    <p:spTree>
+      <p:nvGrpSpPr>
+        <p:cNvPr id="1" name=""/>
+        <p:cNvGrpSpPr/>
+        <p:nvPr/>
+      </p:nvGrpSpPr>
+      <p:grpSpPr>
+        <a:xfrm>
+          <a:off x="0" y="0"/>
+          <a:ext cx="0" cy="0"/>
+          <a:chOff x="0" y="0"/>
+          <a:chExt cx="0" cy="0"/>
+        </a:xfrm>
+      </p:grpSpPr>
+      <p:sp>
+        <p:nvSpPr>
+          <p:cNvPr id="2" name="Slide Image Placeholder 1"/>
+          <p:cNvSpPr>
+            <a:spLocks noGrp="1"/>
+          </p:cNvSpPr>
+          <p:nvPr>
+            <p:ph type="sldImg" idx="2"/>
+          </p:nvPr>
+        </p:nvSpPr>
+        <p:spPr/>
+      </p:sp>
+      <p:sp>
+        <p:nvSpPr>
+          <p:cNvPr id="3" name="Notes Placeholder 2"/>
+          <p:cNvSpPr>
+            <a:spLocks noGrp="1"/>
+          </p:cNvSpPr>
+          <p:nvPr>
+            <p:ph type="body" idx="3" sz="quarter"/>
+          </p:nvPr>
+        </p:nvSpPr>
+        <p:spPr/>
+        <p:txBody>
+          <a:bodyPr/>
+          <a:lstStyle/>
+          <a:p>
+            <a:r>
               <a:t>LIVE, 2 minutes. The faculty session (tentative) picks up autocorrelation and smoothing from here</a:t>
             </a:r>
           </a:p>
@@ -990,7 +1334,7 @@
           <a:lstStyle/>
           <a:p>
             <a:r>
-              <a:t>LIVE, 10 minutes. Groups run notebook 02 with the split moved to 24 August 2026, or read this table.</a:t>
+              <a:t>LIVE, 8 minutes. Groups run notebook 06 with the split moved to 24 August 2026, or read this table.</a:t>
             </a:r>
           </a:p>
           <a:p>
@@ -1070,7 +1414,7 @@
           <a:lstStyle/>
           <a:p>
             <a:r>
-              <a:t>LIVE, 4 minutes. Vote, argue for one minute, vote again. a and c are partly true; b is the cause.</a:t>
+              <a:t>LIVE, 5 minutes. Vote, argue for one minute, vote again. a and c are partly true; b is the cause.</a:t>
             </a:r>
           </a:p>
           <a:p>
@@ -1220,7 +1564,7 @@
           <a:lstStyle/>
           <a:p>
             <a:r>
-              <a:t>LIVE, 6 minutes. Each group writes one line: what a four-week test would have let the vendor's</a:t>
+              <a:t>LIVE, 5 minutes. Each group writes one line: what a four-week test would have let the vendor's</a:t>
             </a:r>
           </a:p>
           <a:p>
@@ -1295,7 +1639,7 @@
           <a:lstStyle/>
           <a:p>
             <a:r>
-              <a:t>LIVE, 4 minutes. This is the rolling-origin picture of FPP3's section 5.10 (checked 12 October</a:t>
+              <a:t>LIVE, 5 minutes. This is the rolling-origin picture of FPP3's section 5.10 (checked 12 October</a:t>
             </a:r>
           </a:p>
           <a:p>
@@ -1370,7 +1714,7 @@
           <a:lstStyle/>
           <a:p>
             <a:r>
-              <a:t>LIVE, 10 minutes. Each group takes one row and calls out its two misses. Festival-aligned copies</a:t>
+              <a:t>LIVE, 12 minutes. Each group takes one row and calls out its two misses. Festival-aligned copies</a:t>
             </a:r>
           </a:p>
           <a:p>
@@ -1445,7 +1789,7 @@
           <a:lstStyle/>
           <a:p>
             <a:r>
-              <a:t>LIVE, 3 minutes. Groups add their row's misses to the board first. Transition: the answer.</a:t>
+              <a:t>LIVE, 5 minutes. Groups add their row's misses to the board first. Transition: the answer.</a:t>
             </a:r>
           </a:p>
         </p:txBody>
@@ -1515,12 +1859,12 @@
           <a:lstStyle/>
           <a:p>
             <a:r>
-              <a:t>LIVE, 3 minutes. 71,180 over 2,040 is about thirty-five: b was the closest option. Transition:</a:t>
-            </a:r>
-          </a:p>
-          <a:p>
-            <a:r>
-              <a:t>part 3, two real failures.</a:t>
+              <a:t>LIVE, 8 minutes. 71,180 over 2,040 is about thirty-five: b was the closest option. Transition:</a:t>
+            </a:r>
+          </a:p>
+          <a:p>
+            <a:r>
+              <a:t>part 3, how far above the forecast the plan should sit.</a:t>
             </a:r>
           </a:p>
         </p:txBody>
@@ -4674,7 +5018,7 @@
                 </a:solidFill>
                 <a:latin typeface="Calibri"/>
               </a:rPr>
-              <a:t>WEEK 4  ·  FRIDAY  ·  FLIPKART, LUCKNOW  ·  FALLBACK</a:t>
+              <a:t>WEEK 4  ·  FRIDAY  ·  FORECASTING BASICS  ·  FALLBACK</a:t>
             </a:r>
           </a:p>
         </p:txBody>
@@ -4709,7 +5053,7 @@
                 </a:solidFill>
                 <a:latin typeface="Georgia"/>
               </a:rPr>
-              <a:t>Four parts, each testing the morning's choice</a:t>
+              <a:t>Five parts, each testing the day's choice</a:t>
             </a:r>
           </a:p>
         </p:txBody>
@@ -4751,7 +5095,7 @@
       </p:sp>
       <p:pic>
         <p:nvPicPr>
-          <p:cNvPr id="9" name="mermaid diagram" descr="f7bebd1c83210485.png"/>
+          <p:cNvPr id="9" name="mermaid diagram" descr="318abff76339a967.png"/>
           <p:cNvPicPr>
             <a:picLocks noChangeAspect="1"/>
           </p:cNvPicPr>
@@ -4765,8 +5109,8 @@
         </p:blipFill>
         <p:spPr>
           <a:xfrm>
-            <a:off x="780897" y="1956816"/>
-            <a:ext cx="10629900" cy="1600200"/>
+            <a:off x="530352" y="1956816"/>
+            <a:ext cx="11130991" cy="1748136"/>
           </a:xfrm>
           <a:prstGeom prst="rect">
             <a:avLst/>
@@ -4781,7 +5125,7 @@
         </p:nvSpPr>
         <p:spPr>
           <a:xfrm>
-            <a:off x="530352" y="3703320"/>
+            <a:off x="530352" y="3851256"/>
             <a:ext cx="11130991" cy="772160"/>
           </a:xfrm>
           <a:prstGeom prst="rect">
@@ -4842,7 +5186,7 @@
                 </a:solidFill>
                 <a:latin typeface="Calibri"/>
               </a:rPr>
-              <a:t>Week 4 Day 5: how much is coming, and how wrong could we be</a:t>
+              <a:t>Week 4, Day 5. Forecasting basics: the fallback hour</a:t>
             </a:r>
           </a:p>
         </p:txBody>
@@ -4877,7 +5221,7 @@
                 </a:solidFill>
                 <a:latin typeface="Calibri"/>
               </a:rPr>
-              <a:t>S1  ·  1 / 14</a:t>
+              <a:t>S1  ·  1 / 18</a:t>
             </a:r>
           </a:p>
         </p:txBody>
@@ -5048,7 +5392,3261 @@
                 </a:solidFill>
                 <a:latin typeface="Calibri"/>
               </a:rPr>
-              <a:t>WEEK 4  ·  FRIDAY  ·  FLIPKART, LUCKNOW  ·  FALLBACK</a:t>
+              <a:t>WEEK 4  ·  FRIDAY  ·  FORECASTING BASICS  ·  FALLBACK</a:t>
+            </a:r>
+          </a:p>
+        </p:txBody>
+      </p:sp>
+      <p:sp>
+        <p:nvSpPr>
+          <p:cNvPr id="7" name="TextBox 6"/>
+          <p:cNvSpPr txBox="1"/>
+          <p:nvPr/>
+        </p:nvSpPr>
+        <p:spPr>
+          <a:xfrm>
+            <a:off x="530352" y="676656"/>
+            <a:ext cx="11130991" cy="512064"/>
+          </a:xfrm>
+          <a:prstGeom prst="rect">
+            <a:avLst/>
+          </a:prstGeom>
+          <a:noFill/>
+        </p:spPr>
+        <p:txBody>
+          <a:bodyPr wrap="square" anchor="b" lIns="0" rIns="0" tIns="0" bIns="0">
+            <a:spAutoFit/>
+          </a:bodyPr>
+          <a:lstStyle/>
+          <a:p>
+            <a:pPr algn="l"/>
+            <a:r>
+              <a:rPr sz="2600" b="0" i="0">
+                <a:solidFill>
+                  <a:srgbClr val="1A0F5C"/>
+                </a:solidFill>
+                <a:latin typeface="Georgia"/>
+              </a:rPr>
+              <a:t>Beyond the row: how far above the forecast?</a:t>
+            </a:r>
+          </a:p>
+        </p:txBody>
+      </p:sp>
+      <p:sp>
+        <p:nvSpPr>
+          <p:cNvPr id="8" name="TextBox 7"/>
+          <p:cNvSpPr txBox="1"/>
+          <p:nvPr/>
+        </p:nvSpPr>
+        <p:spPr>
+          <a:xfrm>
+            <a:off x="530352" y="1243584"/>
+            <a:ext cx="11130991" cy="234696"/>
+          </a:xfrm>
+          <a:prstGeom prst="rect">
+            <a:avLst/>
+          </a:prstGeom>
+          <a:noFill/>
+        </p:spPr>
+        <p:txBody>
+          <a:bodyPr wrap="square" anchor="t" lIns="0" rIns="0" tIns="0" bIns="0">
+            <a:spAutoFit/>
+          </a:bodyPr>
+          <a:lstStyle/>
+          <a:p>
+            <a:pPr algn="l"/>
+            <a:r>
+              <a:rPr sz="1200" b="0" i="0">
+                <a:solidFill>
+                  <a:srgbClr val="6B6690"/>
+                </a:solidFill>
+                <a:latin typeface="Calibri"/>
+              </a:rPr>
+              <a:t>The day booked the forecast itself, and a late shipment costs 4.6 times a spare one. Where should the plan sit?</a:t>
+            </a:r>
+          </a:p>
+        </p:txBody>
+      </p:sp>
+      <p:sp>
+        <p:nvSpPr>
+          <p:cNvPr id="9" name="Rounded Rectangle 8"/>
+          <p:cNvSpPr/>
+          <p:nvPr/>
+        </p:nvSpPr>
+        <p:spPr>
+          <a:xfrm>
+            <a:off x="530352" y="1956816"/>
+            <a:ext cx="2645587" cy="2195576"/>
+          </a:xfrm>
+          <a:prstGeom prst="roundRect">
+            <a:avLst>
+              <a:gd name="adj" fmla="val 5000"/>
+            </a:avLst>
+          </a:prstGeom>
+          <a:solidFill>
+            <a:srgbClr val="FFFFFF"/>
+          </a:solidFill>
+          <a:ln w="9525">
+            <a:solidFill>
+              <a:srgbClr val="E4E1F1"/>
+            </a:solidFill>
+          </a:ln>
+          <a:effectLst>
+            <a:outerShdw blurRad="76200" dist="19050" dir="5400000" algn="bl" rotWithShape="0">
+              <a:srgbClr val="1A0F5C">
+                <a:alpha val="12000"/>
+              </a:srgbClr>
+            </a:outerShdw>
+          </a:effectLst>
+        </p:spPr>
+        <p:style>
+          <a:lnRef idx="1">
+            <a:schemeClr val="accent1"/>
+          </a:lnRef>
+          <a:fillRef idx="3">
+            <a:schemeClr val="accent1"/>
+          </a:fillRef>
+          <a:effectRef idx="2">
+            <a:schemeClr val="accent1"/>
+          </a:effectRef>
+          <a:fontRef idx="minor">
+            <a:schemeClr val="lt1"/>
+          </a:fontRef>
+        </p:style>
+        <p:txBody>
+          <a:bodyPr rtlCol="0" anchor="ctr" wrap="square"/>
+          <a:lstStyle/>
+          <a:p>
+            <a:pPr algn="ctr"/>
+          </a:p>
+        </p:txBody>
+      </p:sp>
+      <p:sp>
+        <p:nvSpPr>
+          <p:cNvPr id="10" name="Oval 9"/>
+          <p:cNvSpPr/>
+          <p:nvPr/>
+        </p:nvSpPr>
+        <p:spPr>
+          <a:xfrm>
+            <a:off x="731519" y="2157984"/>
+            <a:ext cx="457200" cy="457200"/>
+          </a:xfrm>
+          <a:prstGeom prst="ellipse">
+            <a:avLst/>
+          </a:prstGeom>
+          <a:solidFill>
+            <a:srgbClr val="EEEAFB"/>
+          </a:solidFill>
+          <a:ln>
+            <a:noFill/>
+          </a:ln>
+          <a:effectLst/>
+        </p:spPr>
+        <p:style>
+          <a:lnRef idx="1">
+            <a:schemeClr val="accent1"/>
+          </a:lnRef>
+          <a:fillRef idx="3">
+            <a:schemeClr val="accent1"/>
+          </a:fillRef>
+          <a:effectRef idx="2">
+            <a:schemeClr val="accent1"/>
+          </a:effectRef>
+          <a:fontRef idx="minor">
+            <a:schemeClr val="lt1"/>
+          </a:fontRef>
+        </p:style>
+        <p:txBody>
+          <a:bodyPr rtlCol="0" anchor="ctr" wrap="square"/>
+          <a:lstStyle/>
+          <a:p>
+            <a:pPr algn="ctr"/>
+          </a:p>
+        </p:txBody>
+      </p:sp>
+      <p:pic>
+        <p:nvPicPr>
+          <p:cNvPr id="11" name="Picture 10" descr="list_637b34e7c72a.png"/>
+          <p:cNvPicPr>
+            <a:picLocks noChangeAspect="1"/>
+          </p:cNvPicPr>
+          <p:nvPr/>
+        </p:nvPicPr>
+        <p:blipFill>
+          <a:blip r:embed="rId4"/>
+          <a:stretch>
+            <a:fillRect/>
+          </a:stretch>
+        </p:blipFill>
+        <p:spPr>
+          <a:xfrm>
+            <a:off x="841247" y="2267712"/>
+            <a:ext cx="237744" cy="237744"/>
+          </a:xfrm>
+          <a:prstGeom prst="rect">
+            <a:avLst/>
+          </a:prstGeom>
+        </p:spPr>
+      </p:pic>
+      <p:sp>
+        <p:nvSpPr>
+          <p:cNvPr id="12" name="TextBox 11"/>
+          <p:cNvSpPr txBox="1"/>
+          <p:nvPr/>
+        </p:nvSpPr>
+        <p:spPr>
+          <a:xfrm>
+            <a:off x="731519" y="2724912"/>
+            <a:ext cx="2243251" cy="160401"/>
+          </a:xfrm>
+          <a:prstGeom prst="rect">
+            <a:avLst/>
+          </a:prstGeom>
+          <a:noFill/>
+        </p:spPr>
+        <p:txBody>
+          <a:bodyPr wrap="square" anchor="t" lIns="0" rIns="0" tIns="0" bIns="0">
+            <a:spAutoFit/>
+          </a:bodyPr>
+          <a:lstStyle/>
+          <a:p>
+            <a:pPr algn="l"/>
+            <a:r>
+              <a:rPr sz="750" b="1" i="0" spc="250">
+                <a:solidFill>
+                  <a:srgbClr val="5B3FD6"/>
+                </a:solidFill>
+                <a:latin typeface="Calibri"/>
+              </a:rPr>
+              <a:t>A</a:t>
+            </a:r>
+          </a:p>
+        </p:txBody>
+      </p:sp>
+      <p:sp>
+        <p:nvSpPr>
+          <p:cNvPr id="13" name="TextBox 12"/>
+          <p:cNvSpPr txBox="1"/>
+          <p:nvPr/>
+        </p:nvSpPr>
+        <p:spPr>
+          <a:xfrm>
+            <a:off x="731519" y="2962656"/>
+            <a:ext cx="2243251" cy="267716"/>
+          </a:xfrm>
+          <a:prstGeom prst="rect">
+            <a:avLst/>
+          </a:prstGeom>
+          <a:noFill/>
+        </p:spPr>
+        <p:txBody>
+          <a:bodyPr wrap="square" anchor="t" lIns="0" rIns="0" tIns="0" bIns="0">
+            <a:spAutoFit/>
+          </a:bodyPr>
+          <a:lstStyle/>
+          <a:p>
+            <a:pPr algn="l"/>
+            <a:r>
+              <a:rPr sz="1400" b="1" i="0">
+                <a:solidFill>
+                  <a:srgbClr val="1A0F5C"/>
+                </a:solidFill>
+                <a:latin typeface="Calibri"/>
+              </a:rPr>
+              <a:t>At the forecast</a:t>
+            </a:r>
+          </a:p>
+        </p:txBody>
+      </p:sp>
+      <p:sp>
+        <p:nvSpPr>
+          <p:cNvPr id="14" name="TextBox 13"/>
+          <p:cNvSpPr txBox="1"/>
+          <p:nvPr/>
+        </p:nvSpPr>
+        <p:spPr>
+          <a:xfrm>
+            <a:off x="731519" y="3303524"/>
+            <a:ext cx="2243251" cy="399796"/>
+          </a:xfrm>
+          <a:prstGeom prst="rect">
+            <a:avLst/>
+          </a:prstGeom>
+          <a:noFill/>
+        </p:spPr>
+        <p:txBody>
+          <a:bodyPr wrap="square" anchor="t" lIns="0" rIns="0" tIns="0" bIns="0">
+            <a:spAutoFit/>
+          </a:bodyPr>
+          <a:lstStyle/>
+          <a:p>
+            <a:pPr algn="l"/>
+            <a:r>
+              <a:rPr sz="1100" b="0" i="0">
+                <a:solidFill>
+                  <a:srgbClr val="6B6690"/>
+                </a:solidFill>
+                <a:latin typeface="Calibri"/>
+              </a:rPr>
+              <a:t>Covering demand in about half the weeks.</a:t>
+            </a:r>
+          </a:p>
+        </p:txBody>
+      </p:sp>
+      <p:sp>
+        <p:nvSpPr>
+          <p:cNvPr id="15" name="Rounded Rectangle 14"/>
+          <p:cNvSpPr/>
+          <p:nvPr/>
+        </p:nvSpPr>
+        <p:spPr>
+          <a:xfrm>
+            <a:off x="3358819" y="1956816"/>
+            <a:ext cx="2645587" cy="2195576"/>
+          </a:xfrm>
+          <a:prstGeom prst="roundRect">
+            <a:avLst>
+              <a:gd name="adj" fmla="val 5000"/>
+            </a:avLst>
+          </a:prstGeom>
+          <a:solidFill>
+            <a:srgbClr val="FFFFFF"/>
+          </a:solidFill>
+          <a:ln w="9525">
+            <a:solidFill>
+              <a:srgbClr val="E4E1F1"/>
+            </a:solidFill>
+          </a:ln>
+          <a:effectLst>
+            <a:outerShdw blurRad="76200" dist="19050" dir="5400000" algn="bl" rotWithShape="0">
+              <a:srgbClr val="1A0F5C">
+                <a:alpha val="12000"/>
+              </a:srgbClr>
+            </a:outerShdw>
+          </a:effectLst>
+        </p:spPr>
+        <p:style>
+          <a:lnRef idx="1">
+            <a:schemeClr val="accent1"/>
+          </a:lnRef>
+          <a:fillRef idx="3">
+            <a:schemeClr val="accent1"/>
+          </a:fillRef>
+          <a:effectRef idx="2">
+            <a:schemeClr val="accent1"/>
+          </a:effectRef>
+          <a:fontRef idx="minor">
+            <a:schemeClr val="lt1"/>
+          </a:fontRef>
+        </p:style>
+        <p:txBody>
+          <a:bodyPr rtlCol="0" anchor="ctr" wrap="square"/>
+          <a:lstStyle/>
+          <a:p>
+            <a:pPr algn="ctr"/>
+          </a:p>
+        </p:txBody>
+      </p:sp>
+      <p:sp>
+        <p:nvSpPr>
+          <p:cNvPr id="16" name="Oval 15"/>
+          <p:cNvSpPr/>
+          <p:nvPr/>
+        </p:nvSpPr>
+        <p:spPr>
+          <a:xfrm>
+            <a:off x="3559987" y="2157984"/>
+            <a:ext cx="457200" cy="457200"/>
+          </a:xfrm>
+          <a:prstGeom prst="ellipse">
+            <a:avLst/>
+          </a:prstGeom>
+          <a:solidFill>
+            <a:srgbClr val="EEEAFB"/>
+          </a:solidFill>
+          <a:ln>
+            <a:noFill/>
+          </a:ln>
+          <a:effectLst/>
+        </p:spPr>
+        <p:style>
+          <a:lnRef idx="1">
+            <a:schemeClr val="accent1"/>
+          </a:lnRef>
+          <a:fillRef idx="3">
+            <a:schemeClr val="accent1"/>
+          </a:fillRef>
+          <a:effectRef idx="2">
+            <a:schemeClr val="accent1"/>
+          </a:effectRef>
+          <a:fontRef idx="minor">
+            <a:schemeClr val="lt1"/>
+          </a:fontRef>
+        </p:style>
+        <p:txBody>
+          <a:bodyPr rtlCol="0" anchor="ctr" wrap="square"/>
+          <a:lstStyle/>
+          <a:p>
+            <a:pPr algn="ctr"/>
+          </a:p>
+        </p:txBody>
+      </p:sp>
+      <p:pic>
+        <p:nvPicPr>
+          <p:cNvPr id="17" name="Picture 16" descr="list_637b34e7c72a.png"/>
+          <p:cNvPicPr>
+            <a:picLocks noChangeAspect="1"/>
+          </p:cNvPicPr>
+          <p:nvPr/>
+        </p:nvPicPr>
+        <p:blipFill>
+          <a:blip r:embed="rId4"/>
+          <a:stretch>
+            <a:fillRect/>
+          </a:stretch>
+        </p:blipFill>
+        <p:spPr>
+          <a:xfrm>
+            <a:off x="3669715" y="2267712"/>
+            <a:ext cx="237744" cy="237744"/>
+          </a:xfrm>
+          <a:prstGeom prst="rect">
+            <a:avLst/>
+          </a:prstGeom>
+        </p:spPr>
+      </p:pic>
+      <p:sp>
+        <p:nvSpPr>
+          <p:cNvPr id="18" name="TextBox 17"/>
+          <p:cNvSpPr txBox="1"/>
+          <p:nvPr/>
+        </p:nvSpPr>
+        <p:spPr>
+          <a:xfrm>
+            <a:off x="3559987" y="2724912"/>
+            <a:ext cx="2243251" cy="160401"/>
+          </a:xfrm>
+          <a:prstGeom prst="rect">
+            <a:avLst/>
+          </a:prstGeom>
+          <a:noFill/>
+        </p:spPr>
+        <p:txBody>
+          <a:bodyPr wrap="square" anchor="t" lIns="0" rIns="0" tIns="0" bIns="0">
+            <a:spAutoFit/>
+          </a:bodyPr>
+          <a:lstStyle/>
+          <a:p>
+            <a:pPr algn="l"/>
+            <a:r>
+              <a:rPr sz="750" b="1" i="0" spc="250">
+                <a:solidFill>
+                  <a:srgbClr val="5B3FD6"/>
+                </a:solidFill>
+                <a:latin typeface="Calibri"/>
+              </a:rPr>
+              <a:t>B</a:t>
+            </a:r>
+          </a:p>
+        </p:txBody>
+      </p:sp>
+      <p:sp>
+        <p:nvSpPr>
+          <p:cNvPr id="19" name="TextBox 18"/>
+          <p:cNvSpPr txBox="1"/>
+          <p:nvPr/>
+        </p:nvSpPr>
+        <p:spPr>
+          <a:xfrm>
+            <a:off x="3559987" y="2962656"/>
+            <a:ext cx="2243251" cy="267716"/>
+          </a:xfrm>
+          <a:prstGeom prst="rect">
+            <a:avLst/>
+          </a:prstGeom>
+          <a:noFill/>
+        </p:spPr>
+        <p:txBody>
+          <a:bodyPr wrap="square" anchor="t" lIns="0" rIns="0" tIns="0" bIns="0">
+            <a:spAutoFit/>
+          </a:bodyPr>
+          <a:lstStyle/>
+          <a:p>
+            <a:pPr algn="l"/>
+            <a:r>
+              <a:rPr sz="1400" b="1" i="0">
+                <a:solidFill>
+                  <a:srgbClr val="1A0F5C"/>
+                </a:solidFill>
+                <a:latin typeface="Calibri"/>
+              </a:rPr>
+              <a:t>Above the forecast</a:t>
+            </a:r>
+          </a:p>
+        </p:txBody>
+      </p:sp>
+      <p:sp>
+        <p:nvSpPr>
+          <p:cNvPr id="20" name="TextBox 19"/>
+          <p:cNvSpPr txBox="1"/>
+          <p:nvPr/>
+        </p:nvSpPr>
+        <p:spPr>
+          <a:xfrm>
+            <a:off x="3559987" y="3303524"/>
+            <a:ext cx="2243251" cy="399796"/>
+          </a:xfrm>
+          <a:prstGeom prst="rect">
+            <a:avLst/>
+          </a:prstGeom>
+          <a:noFill/>
+        </p:spPr>
+        <p:txBody>
+          <a:bodyPr wrap="square" anchor="t" lIns="0" rIns="0" tIns="0" bIns="0">
+            <a:spAutoFit/>
+          </a:bodyPr>
+          <a:lstStyle/>
+          <a:p>
+            <a:pPr algn="l"/>
+            <a:r>
+              <a:rPr sz="1100" b="0" i="0">
+                <a:solidFill>
+                  <a:srgbClr val="6B6690"/>
+                </a:solidFill>
+                <a:latin typeface="Calibri"/>
+              </a:rPr>
+              <a:t>Covering demand in about four weeks of five.</a:t>
+            </a:r>
+          </a:p>
+        </p:txBody>
+      </p:sp>
+      <p:sp>
+        <p:nvSpPr>
+          <p:cNvPr id="21" name="Rounded Rectangle 20"/>
+          <p:cNvSpPr/>
+          <p:nvPr/>
+        </p:nvSpPr>
+        <p:spPr>
+          <a:xfrm>
+            <a:off x="6187287" y="1956816"/>
+            <a:ext cx="2645587" cy="2195576"/>
+          </a:xfrm>
+          <a:prstGeom prst="roundRect">
+            <a:avLst>
+              <a:gd name="adj" fmla="val 5000"/>
+            </a:avLst>
+          </a:prstGeom>
+          <a:solidFill>
+            <a:srgbClr val="FFFFFF"/>
+          </a:solidFill>
+          <a:ln w="9525">
+            <a:solidFill>
+              <a:srgbClr val="E4E1F1"/>
+            </a:solidFill>
+          </a:ln>
+          <a:effectLst>
+            <a:outerShdw blurRad="76200" dist="19050" dir="5400000" algn="bl" rotWithShape="0">
+              <a:srgbClr val="1A0F5C">
+                <a:alpha val="12000"/>
+              </a:srgbClr>
+            </a:outerShdw>
+          </a:effectLst>
+        </p:spPr>
+        <p:style>
+          <a:lnRef idx="1">
+            <a:schemeClr val="accent1"/>
+          </a:lnRef>
+          <a:fillRef idx="3">
+            <a:schemeClr val="accent1"/>
+          </a:fillRef>
+          <a:effectRef idx="2">
+            <a:schemeClr val="accent1"/>
+          </a:effectRef>
+          <a:fontRef idx="minor">
+            <a:schemeClr val="lt1"/>
+          </a:fontRef>
+        </p:style>
+        <p:txBody>
+          <a:bodyPr rtlCol="0" anchor="ctr" wrap="square"/>
+          <a:lstStyle/>
+          <a:p>
+            <a:pPr algn="ctr"/>
+          </a:p>
+        </p:txBody>
+      </p:sp>
+      <p:sp>
+        <p:nvSpPr>
+          <p:cNvPr id="22" name="Oval 21"/>
+          <p:cNvSpPr/>
+          <p:nvPr/>
+        </p:nvSpPr>
+        <p:spPr>
+          <a:xfrm>
+            <a:off x="6388455" y="2157984"/>
+            <a:ext cx="457200" cy="457200"/>
+          </a:xfrm>
+          <a:prstGeom prst="ellipse">
+            <a:avLst/>
+          </a:prstGeom>
+          <a:solidFill>
+            <a:srgbClr val="EEEAFB"/>
+          </a:solidFill>
+          <a:ln>
+            <a:noFill/>
+          </a:ln>
+          <a:effectLst/>
+        </p:spPr>
+        <p:style>
+          <a:lnRef idx="1">
+            <a:schemeClr val="accent1"/>
+          </a:lnRef>
+          <a:fillRef idx="3">
+            <a:schemeClr val="accent1"/>
+          </a:fillRef>
+          <a:effectRef idx="2">
+            <a:schemeClr val="accent1"/>
+          </a:effectRef>
+          <a:fontRef idx="minor">
+            <a:schemeClr val="lt1"/>
+          </a:fontRef>
+        </p:style>
+        <p:txBody>
+          <a:bodyPr rtlCol="0" anchor="ctr" wrap="square"/>
+          <a:lstStyle/>
+          <a:p>
+            <a:pPr algn="ctr"/>
+          </a:p>
+        </p:txBody>
+      </p:sp>
+      <p:pic>
+        <p:nvPicPr>
+          <p:cNvPr id="23" name="Picture 22" descr="list_637b34e7c72a.png"/>
+          <p:cNvPicPr>
+            <a:picLocks noChangeAspect="1"/>
+          </p:cNvPicPr>
+          <p:nvPr/>
+        </p:nvPicPr>
+        <p:blipFill>
+          <a:blip r:embed="rId4"/>
+          <a:stretch>
+            <a:fillRect/>
+          </a:stretch>
+        </p:blipFill>
+        <p:spPr>
+          <a:xfrm>
+            <a:off x="6498183" y="2267712"/>
+            <a:ext cx="237744" cy="237744"/>
+          </a:xfrm>
+          <a:prstGeom prst="rect">
+            <a:avLst/>
+          </a:prstGeom>
+        </p:spPr>
+      </p:pic>
+      <p:sp>
+        <p:nvSpPr>
+          <p:cNvPr id="24" name="TextBox 23"/>
+          <p:cNvSpPr txBox="1"/>
+          <p:nvPr/>
+        </p:nvSpPr>
+        <p:spPr>
+          <a:xfrm>
+            <a:off x="6388455" y="2724912"/>
+            <a:ext cx="2243251" cy="160401"/>
+          </a:xfrm>
+          <a:prstGeom prst="rect">
+            <a:avLst/>
+          </a:prstGeom>
+          <a:noFill/>
+        </p:spPr>
+        <p:txBody>
+          <a:bodyPr wrap="square" anchor="t" lIns="0" rIns="0" tIns="0" bIns="0">
+            <a:spAutoFit/>
+          </a:bodyPr>
+          <a:lstStyle/>
+          <a:p>
+            <a:pPr algn="l"/>
+            <a:r>
+              <a:rPr sz="750" b="1" i="0" spc="250">
+                <a:solidFill>
+                  <a:srgbClr val="5B3FD6"/>
+                </a:solidFill>
+                <a:latin typeface="Calibri"/>
+              </a:rPr>
+              <a:t>C</a:t>
+            </a:r>
+          </a:p>
+        </p:txBody>
+      </p:sp>
+      <p:sp>
+        <p:nvSpPr>
+          <p:cNvPr id="25" name="TextBox 24"/>
+          <p:cNvSpPr txBox="1"/>
+          <p:nvPr/>
+        </p:nvSpPr>
+        <p:spPr>
+          <a:xfrm>
+            <a:off x="6388455" y="2962656"/>
+            <a:ext cx="2243251" cy="498856"/>
+          </a:xfrm>
+          <a:prstGeom prst="rect">
+            <a:avLst/>
+          </a:prstGeom>
+          <a:noFill/>
+        </p:spPr>
+        <p:txBody>
+          <a:bodyPr wrap="square" anchor="t" lIns="0" rIns="0" tIns="0" bIns="0">
+            <a:spAutoFit/>
+          </a:bodyPr>
+          <a:lstStyle/>
+          <a:p>
+            <a:pPr algn="l"/>
+            <a:r>
+              <a:rPr sz="1400" b="1" i="0">
+                <a:solidFill>
+                  <a:srgbClr val="1A0F5C"/>
+                </a:solidFill>
+                <a:latin typeface="Calibri"/>
+              </a:rPr>
+              <a:t>Far enough to cover every week</a:t>
+            </a:r>
+          </a:p>
+        </p:txBody>
+      </p:sp>
+      <p:sp>
+        <p:nvSpPr>
+          <p:cNvPr id="26" name="TextBox 25"/>
+          <p:cNvSpPr txBox="1"/>
+          <p:nvPr/>
+        </p:nvSpPr>
+        <p:spPr>
+          <a:xfrm>
+            <a:off x="6388455" y="3534664"/>
+            <a:ext cx="2243251" cy="399796"/>
+          </a:xfrm>
+          <a:prstGeom prst="rect">
+            <a:avLst/>
+          </a:prstGeom>
+          <a:noFill/>
+        </p:spPr>
+        <p:txBody>
+          <a:bodyPr wrap="square" anchor="t" lIns="0" rIns="0" tIns="0" bIns="0">
+            <a:spAutoFit/>
+          </a:bodyPr>
+          <a:lstStyle/>
+          <a:p>
+            <a:pPr algn="l"/>
+            <a:r>
+              <a:rPr sz="1100" b="0" i="0">
+                <a:solidFill>
+                  <a:srgbClr val="6B6690"/>
+                </a:solidFill>
+                <a:latin typeface="Calibri"/>
+              </a:rPr>
+              <a:t>Since a late parcel is never acceptable.</a:t>
+            </a:r>
+          </a:p>
+        </p:txBody>
+      </p:sp>
+      <p:sp>
+        <p:nvSpPr>
+          <p:cNvPr id="27" name="Rounded Rectangle 26"/>
+          <p:cNvSpPr/>
+          <p:nvPr/>
+        </p:nvSpPr>
+        <p:spPr>
+          <a:xfrm>
+            <a:off x="9015755" y="1956816"/>
+            <a:ext cx="2645587" cy="2195576"/>
+          </a:xfrm>
+          <a:prstGeom prst="roundRect">
+            <a:avLst>
+              <a:gd name="adj" fmla="val 5000"/>
+            </a:avLst>
+          </a:prstGeom>
+          <a:solidFill>
+            <a:srgbClr val="FFFFFF"/>
+          </a:solidFill>
+          <a:ln w="9525">
+            <a:solidFill>
+              <a:srgbClr val="E4E1F1"/>
+            </a:solidFill>
+          </a:ln>
+          <a:effectLst>
+            <a:outerShdw blurRad="76200" dist="19050" dir="5400000" algn="bl" rotWithShape="0">
+              <a:srgbClr val="1A0F5C">
+                <a:alpha val="12000"/>
+              </a:srgbClr>
+            </a:outerShdw>
+          </a:effectLst>
+        </p:spPr>
+        <p:style>
+          <a:lnRef idx="1">
+            <a:schemeClr val="accent1"/>
+          </a:lnRef>
+          <a:fillRef idx="3">
+            <a:schemeClr val="accent1"/>
+          </a:fillRef>
+          <a:effectRef idx="2">
+            <a:schemeClr val="accent1"/>
+          </a:effectRef>
+          <a:fontRef idx="minor">
+            <a:schemeClr val="lt1"/>
+          </a:fontRef>
+        </p:style>
+        <p:txBody>
+          <a:bodyPr rtlCol="0" anchor="ctr" wrap="square"/>
+          <a:lstStyle/>
+          <a:p>
+            <a:pPr algn="ctr"/>
+          </a:p>
+        </p:txBody>
+      </p:sp>
+      <p:sp>
+        <p:nvSpPr>
+          <p:cNvPr id="28" name="Oval 27"/>
+          <p:cNvSpPr/>
+          <p:nvPr/>
+        </p:nvSpPr>
+        <p:spPr>
+          <a:xfrm>
+            <a:off x="9216923" y="2157984"/>
+            <a:ext cx="457200" cy="457200"/>
+          </a:xfrm>
+          <a:prstGeom prst="ellipse">
+            <a:avLst/>
+          </a:prstGeom>
+          <a:solidFill>
+            <a:srgbClr val="EEEAFB"/>
+          </a:solidFill>
+          <a:ln>
+            <a:noFill/>
+          </a:ln>
+          <a:effectLst/>
+        </p:spPr>
+        <p:style>
+          <a:lnRef idx="1">
+            <a:schemeClr val="accent1"/>
+          </a:lnRef>
+          <a:fillRef idx="3">
+            <a:schemeClr val="accent1"/>
+          </a:fillRef>
+          <a:effectRef idx="2">
+            <a:schemeClr val="accent1"/>
+          </a:effectRef>
+          <a:fontRef idx="minor">
+            <a:schemeClr val="lt1"/>
+          </a:fontRef>
+        </p:style>
+        <p:txBody>
+          <a:bodyPr rtlCol="0" anchor="ctr" wrap="square"/>
+          <a:lstStyle/>
+          <a:p>
+            <a:pPr algn="ctr"/>
+          </a:p>
+        </p:txBody>
+      </p:sp>
+      <p:pic>
+        <p:nvPicPr>
+          <p:cNvPr id="29" name="Picture 28" descr="list_637b34e7c72a.png"/>
+          <p:cNvPicPr>
+            <a:picLocks noChangeAspect="1"/>
+          </p:cNvPicPr>
+          <p:nvPr/>
+        </p:nvPicPr>
+        <p:blipFill>
+          <a:blip r:embed="rId4"/>
+          <a:stretch>
+            <a:fillRect/>
+          </a:stretch>
+        </p:blipFill>
+        <p:spPr>
+          <a:xfrm>
+            <a:off x="9326651" y="2267712"/>
+            <a:ext cx="237744" cy="237744"/>
+          </a:xfrm>
+          <a:prstGeom prst="rect">
+            <a:avLst/>
+          </a:prstGeom>
+        </p:spPr>
+      </p:pic>
+      <p:sp>
+        <p:nvSpPr>
+          <p:cNvPr id="30" name="TextBox 29"/>
+          <p:cNvSpPr txBox="1"/>
+          <p:nvPr/>
+        </p:nvSpPr>
+        <p:spPr>
+          <a:xfrm>
+            <a:off x="9216923" y="2724912"/>
+            <a:ext cx="2243251" cy="160401"/>
+          </a:xfrm>
+          <a:prstGeom prst="rect">
+            <a:avLst/>
+          </a:prstGeom>
+          <a:noFill/>
+        </p:spPr>
+        <p:txBody>
+          <a:bodyPr wrap="square" anchor="t" lIns="0" rIns="0" tIns="0" bIns="0">
+            <a:spAutoFit/>
+          </a:bodyPr>
+          <a:lstStyle/>
+          <a:p>
+            <a:pPr algn="l"/>
+            <a:r>
+              <a:rPr sz="750" b="1" i="0" spc="250">
+                <a:solidFill>
+                  <a:srgbClr val="5B3FD6"/>
+                </a:solidFill>
+                <a:latin typeface="Calibri"/>
+              </a:rPr>
+              <a:t>D</a:t>
+            </a:r>
+          </a:p>
+        </p:txBody>
+      </p:sp>
+      <p:sp>
+        <p:nvSpPr>
+          <p:cNvPr id="31" name="TextBox 30"/>
+          <p:cNvSpPr txBox="1"/>
+          <p:nvPr/>
+        </p:nvSpPr>
+        <p:spPr>
+          <a:xfrm>
+            <a:off x="9216923" y="2962656"/>
+            <a:ext cx="2243251" cy="267716"/>
+          </a:xfrm>
+          <a:prstGeom prst="rect">
+            <a:avLst/>
+          </a:prstGeom>
+          <a:noFill/>
+        </p:spPr>
+        <p:txBody>
+          <a:bodyPr wrap="square" anchor="t" lIns="0" rIns="0" tIns="0" bIns="0">
+            <a:spAutoFit/>
+          </a:bodyPr>
+          <a:lstStyle/>
+          <a:p>
+            <a:pPr algn="l"/>
+            <a:r>
+              <a:rPr sz="1400" b="1" i="0">
+                <a:solidFill>
+                  <a:srgbClr val="1A0F5C"/>
+                </a:solidFill>
+                <a:latin typeface="Calibri"/>
+              </a:rPr>
+              <a:t>Below the forecast</a:t>
+            </a:r>
+          </a:p>
+        </p:txBody>
+      </p:sp>
+      <p:sp>
+        <p:nvSpPr>
+          <p:cNvPr id="32" name="TextBox 31"/>
+          <p:cNvSpPr txBox="1"/>
+          <p:nvPr/>
+        </p:nvSpPr>
+        <p:spPr>
+          <a:xfrm>
+            <a:off x="9216923" y="3303524"/>
+            <a:ext cx="2243251" cy="399796"/>
+          </a:xfrm>
+          <a:prstGeom prst="rect">
+            <a:avLst/>
+          </a:prstGeom>
+          <a:noFill/>
+        </p:spPr>
+        <p:txBody>
+          <a:bodyPr wrap="square" anchor="t" lIns="0" rIns="0" tIns="0" bIns="0">
+            <a:spAutoFit/>
+          </a:bodyPr>
+          <a:lstStyle/>
+          <a:p>
+            <a:pPr algn="l"/>
+            <a:r>
+              <a:rPr sz="1100" b="0" i="0">
+                <a:solidFill>
+                  <a:srgbClr val="6B6690"/>
+                </a:solidFill>
+                <a:latin typeface="Calibri"/>
+              </a:rPr>
+              <a:t>Since spare shipments waste money.</a:t>
+            </a:r>
+          </a:p>
+        </p:txBody>
+      </p:sp>
+      <p:sp>
+        <p:nvSpPr>
+          <p:cNvPr id="33" name="TextBox 32"/>
+          <p:cNvSpPr txBox="1"/>
+          <p:nvPr/>
+        </p:nvSpPr>
+        <p:spPr>
+          <a:xfrm>
+            <a:off x="530352" y="4335272"/>
+            <a:ext cx="11130991" cy="772160"/>
+          </a:xfrm>
+          <a:prstGeom prst="rect">
+            <a:avLst/>
+          </a:prstGeom>
+          <a:noFill/>
+        </p:spPr>
+        <p:txBody>
+          <a:bodyPr wrap="square" anchor="t" lIns="0" rIns="0" tIns="0" bIns="0">
+            <a:spAutoFit/>
+          </a:bodyPr>
+          <a:lstStyle/>
+          <a:p>
+            <a:pPr>
+              <a:spcAft>
+                <a:spcPts val="800"/>
+              </a:spcAft>
+            </a:pPr>
+            <a:r>
+              <a:rPr sz="1600" b="0" i="0">
+                <a:solidFill>
+                  <a:srgbClr val="1A1440"/>
+                </a:solidFill>
+                <a:latin typeface="Calibri"/>
+              </a:rPr>
+              <a:t>This part goes beyond the five subtopics of Friday's curriculum row: it is the plan quantile, the spine's addition, taught only in this hour and in notebook 07's depth section.</a:t>
+            </a:r>
+          </a:p>
+        </p:txBody>
+      </p:sp>
+      <p:sp>
+        <p:nvSpPr>
+          <p:cNvPr id="34" name="TextBox 33"/>
+          <p:cNvSpPr txBox="1"/>
+          <p:nvPr/>
+        </p:nvSpPr>
+        <p:spPr>
+          <a:xfrm>
+            <a:off x="530352" y="6437376"/>
+            <a:ext cx="9667951" cy="160401"/>
+          </a:xfrm>
+          <a:prstGeom prst="rect">
+            <a:avLst/>
+          </a:prstGeom>
+          <a:noFill/>
+        </p:spPr>
+        <p:txBody>
+          <a:bodyPr wrap="square" anchor="t" lIns="0" rIns="0" tIns="0" bIns="0">
+            <a:spAutoFit/>
+          </a:bodyPr>
+          <a:lstStyle/>
+          <a:p>
+            <a:pPr algn="l"/>
+            <a:r>
+              <a:rPr sz="750" b="0" i="0">
+                <a:solidFill>
+                  <a:srgbClr val="6B6690"/>
+                </a:solidFill>
+                <a:latin typeface="Calibri"/>
+              </a:rPr>
+              <a:t>Week 4, Day 5. Forecasting basics: the fallback hour</a:t>
+            </a:r>
+          </a:p>
+        </p:txBody>
+      </p:sp>
+      <p:sp>
+        <p:nvSpPr>
+          <p:cNvPr id="35" name="TextBox 34"/>
+          <p:cNvSpPr txBox="1"/>
+          <p:nvPr/>
+        </p:nvSpPr>
+        <p:spPr>
+          <a:xfrm>
+            <a:off x="10198303" y="6437376"/>
+            <a:ext cx="1463040" cy="160401"/>
+          </a:xfrm>
+          <a:prstGeom prst="rect">
+            <a:avLst/>
+          </a:prstGeom>
+          <a:noFill/>
+        </p:spPr>
+        <p:txBody>
+          <a:bodyPr wrap="square" anchor="t" lIns="0" rIns="0" tIns="0" bIns="0">
+            <a:spAutoFit/>
+          </a:bodyPr>
+          <a:lstStyle/>
+          <a:p>
+            <a:pPr algn="r"/>
+            <a:r>
+              <a:rPr sz="750" b="0" i="0">
+                <a:solidFill>
+                  <a:srgbClr val="6B6690"/>
+                </a:solidFill>
+                <a:latin typeface="Calibri"/>
+              </a:rPr>
+              <a:t>S10  ·  10 / 18</a:t>
+            </a:r>
+          </a:p>
+        </p:txBody>
+      </p:sp>
+    </p:spTree>
+  </p:cSld>
+  <p:clrMapOvr>
+    <a:masterClrMapping/>
+  </p:clrMapOvr>
+</p:sld>
+</file>
+
+<file path=ppt/slides/slide11.xml><?xml version="1.0" encoding="utf-8"?>
+<p:sld xmlns:a="http://schemas.openxmlformats.org/drawingml/2006/main" xmlns:p="http://schemas.openxmlformats.org/presentationml/2006/main" xmlns:r="http://schemas.openxmlformats.org/officeDocument/2006/relationships">
+  <p:cSld>
+    <p:spTree>
+      <p:nvGrpSpPr>
+        <p:cNvPr id="1" name=""/>
+        <p:cNvGrpSpPr/>
+        <p:nvPr/>
+      </p:nvGrpSpPr>
+      <p:grpSpPr/>
+      <p:pic>
+        <p:nvPicPr>
+          <p:cNvPr id="2" name="Picture 1" descr="bg_light.jpg"/>
+          <p:cNvPicPr>
+            <a:picLocks noChangeAspect="1"/>
+          </p:cNvPicPr>
+          <p:nvPr/>
+        </p:nvPicPr>
+        <p:blipFill>
+          <a:blip r:embed="rId2"/>
+          <a:stretch>
+            <a:fillRect/>
+          </a:stretch>
+        </p:blipFill>
+        <p:spPr>
+          <a:xfrm>
+            <a:off x="0" y="0"/>
+            <a:ext cx="12191695" cy="6858000"/>
+          </a:xfrm>
+          <a:prstGeom prst="rect">
+            <a:avLst/>
+          </a:prstGeom>
+        </p:spPr>
+      </p:pic>
+      <p:pic>
+        <p:nvPicPr>
+          <p:cNvPr id="3" name="Picture 2" descr="iitgn_logo.png"/>
+          <p:cNvPicPr>
+            <a:picLocks noChangeAspect="1"/>
+          </p:cNvPicPr>
+          <p:nvPr/>
+        </p:nvPicPr>
+        <p:blipFill>
+          <a:blip r:embed="rId3"/>
+          <a:stretch>
+            <a:fillRect/>
+          </a:stretch>
+        </p:blipFill>
+        <p:spPr>
+          <a:xfrm>
+            <a:off x="530352" y="201168"/>
+            <a:ext cx="420624" cy="420624"/>
+          </a:xfrm>
+          <a:prstGeom prst="rect">
+            <a:avLst/>
+          </a:prstGeom>
+        </p:spPr>
+      </p:pic>
+      <p:sp>
+        <p:nvSpPr>
+          <p:cNvPr id="4" name="TextBox 3"/>
+          <p:cNvSpPr txBox="1"/>
+          <p:nvPr/>
+        </p:nvSpPr>
+        <p:spPr>
+          <a:xfrm>
+            <a:off x="1042416" y="228600"/>
+            <a:ext cx="5120640" cy="185166"/>
+          </a:xfrm>
+          <a:prstGeom prst="rect">
+            <a:avLst/>
+          </a:prstGeom>
+          <a:noFill/>
+        </p:spPr>
+        <p:txBody>
+          <a:bodyPr wrap="square" anchor="t" lIns="0" rIns="0" tIns="0" bIns="0">
+            <a:spAutoFit/>
+          </a:bodyPr>
+          <a:lstStyle/>
+          <a:p>
+            <a:pPr algn="l"/>
+            <a:r>
+              <a:rPr sz="900" b="1" i="0">
+                <a:solidFill>
+                  <a:srgbClr val="1A0F5C"/>
+                </a:solidFill>
+                <a:latin typeface="Calibri"/>
+              </a:rPr>
+              <a:t>Indian Institute of Technology Gandhinagar</a:t>
+            </a:r>
+          </a:p>
+        </p:txBody>
+      </p:sp>
+      <p:sp>
+        <p:nvSpPr>
+          <p:cNvPr id="5" name="TextBox 4"/>
+          <p:cNvSpPr txBox="1"/>
+          <p:nvPr/>
+        </p:nvSpPr>
+        <p:spPr>
+          <a:xfrm>
+            <a:off x="1042416" y="420623"/>
+            <a:ext cx="5852160" cy="127381"/>
+          </a:xfrm>
+          <a:prstGeom prst="rect">
+            <a:avLst/>
+          </a:prstGeom>
+          <a:noFill/>
+        </p:spPr>
+        <p:txBody>
+          <a:bodyPr wrap="square" anchor="t" lIns="0" rIns="0" tIns="0" bIns="0">
+            <a:spAutoFit/>
+          </a:bodyPr>
+          <a:lstStyle/>
+          <a:p>
+            <a:pPr algn="l"/>
+            <a:r>
+              <a:rPr sz="550" b="1" i="0" spc="300">
+                <a:solidFill>
+                  <a:srgbClr val="6B6690"/>
+                </a:solidFill>
+                <a:latin typeface="Calibri"/>
+              </a:rPr>
+              <a:t>ADMINISTERED THROUGH THE COMPETENCY ADVANCEMENT ACADEMY</a:t>
+            </a:r>
+          </a:p>
+        </p:txBody>
+      </p:sp>
+      <p:sp>
+        <p:nvSpPr>
+          <p:cNvPr id="6" name="TextBox 5"/>
+          <p:cNvSpPr txBox="1"/>
+          <p:nvPr/>
+        </p:nvSpPr>
+        <p:spPr>
+          <a:xfrm>
+            <a:off x="5992063" y="310896"/>
+            <a:ext cx="5669280" cy="127381"/>
+          </a:xfrm>
+          <a:prstGeom prst="rect">
+            <a:avLst/>
+          </a:prstGeom>
+          <a:noFill/>
+        </p:spPr>
+        <p:txBody>
+          <a:bodyPr wrap="square" anchor="t" lIns="0" rIns="0" tIns="0" bIns="0">
+            <a:spAutoFit/>
+          </a:bodyPr>
+          <a:lstStyle/>
+          <a:p>
+            <a:pPr algn="r"/>
+            <a:r>
+              <a:rPr sz="550" b="1" i="0" spc="300">
+                <a:solidFill>
+                  <a:srgbClr val="6B6690"/>
+                </a:solidFill>
+                <a:latin typeface="Calibri"/>
+              </a:rPr>
+              <a:t>WEEK 4  ·  FRIDAY  ·  FORECASTING BASICS  ·  FALLBACK</a:t>
+            </a:r>
+          </a:p>
+        </p:txBody>
+      </p:sp>
+      <p:sp>
+        <p:nvSpPr>
+          <p:cNvPr id="7" name="TextBox 6"/>
+          <p:cNvSpPr txBox="1"/>
+          <p:nvPr/>
+        </p:nvSpPr>
+        <p:spPr>
+          <a:xfrm>
+            <a:off x="530352" y="676656"/>
+            <a:ext cx="11130991" cy="512064"/>
+          </a:xfrm>
+          <a:prstGeom prst="rect">
+            <a:avLst/>
+          </a:prstGeom>
+          <a:noFill/>
+        </p:spPr>
+        <p:txBody>
+          <a:bodyPr wrap="square" anchor="b" lIns="0" rIns="0" tIns="0" bIns="0">
+            <a:spAutoFit/>
+          </a:bodyPr>
+          <a:lstStyle/>
+          <a:p>
+            <a:pPr algn="l"/>
+            <a:r>
+              <a:rPr sz="2600" b="0" i="0">
+                <a:solidFill>
+                  <a:srgbClr val="1A0F5C"/>
+                </a:solidFill>
+                <a:latin typeface="Georgia"/>
+              </a:rPr>
+              <a:t>Answer: cover 0.82 of weeks, 25 over 25 plus 5.42</a:t>
+            </a:r>
+          </a:p>
+        </p:txBody>
+      </p:sp>
+      <p:sp>
+        <p:nvSpPr>
+          <p:cNvPr id="8" name="TextBox 7"/>
+          <p:cNvSpPr txBox="1"/>
+          <p:nvPr/>
+        </p:nvSpPr>
+        <p:spPr>
+          <a:xfrm>
+            <a:off x="530352" y="1243584"/>
+            <a:ext cx="11130991" cy="234696"/>
+          </a:xfrm>
+          <a:prstGeom prst="rect">
+            <a:avLst/>
+          </a:prstGeom>
+          <a:noFill/>
+        </p:spPr>
+        <p:txBody>
+          <a:bodyPr wrap="square" anchor="t" lIns="0" rIns="0" tIns="0" bIns="0">
+            <a:spAutoFit/>
+          </a:bodyPr>
+          <a:lstStyle/>
+          <a:p>
+            <a:pPr algn="l"/>
+            <a:r>
+              <a:rPr sz="1200" b="0" i="0">
+                <a:solidFill>
+                  <a:srgbClr val="6B6690"/>
+                </a:solidFill>
+                <a:latin typeface="Calibri"/>
+              </a:rPr>
+              <a:t>Why should the plan sit above the forecast, and how far?</a:t>
+            </a:r>
+          </a:p>
+        </p:txBody>
+      </p:sp>
+      <p:pic>
+        <p:nvPicPr>
+          <p:cNvPr id="9" name="mermaid diagram" descr="C2_W04_D05_cost_curve_STUDENT.png"/>
+          <p:cNvPicPr>
+            <a:picLocks noChangeAspect="1"/>
+          </p:cNvPicPr>
+          <p:nvPr/>
+        </p:nvPicPr>
+        <p:blipFill>
+          <a:blip r:embed="rId4"/>
+          <a:stretch>
+            <a:fillRect/>
+          </a:stretch>
+        </p:blipFill>
+        <p:spPr>
+          <a:xfrm>
+            <a:off x="2389245" y="1664208"/>
+            <a:ext cx="7413204" cy="3319272"/>
+          </a:xfrm>
+          <a:prstGeom prst="rect">
+            <a:avLst/>
+          </a:prstGeom>
+        </p:spPr>
+      </p:pic>
+      <p:sp>
+        <p:nvSpPr>
+          <p:cNvPr id="10" name="picture caption"/>
+          <p:cNvSpPr txBox="1"/>
+          <p:nvPr/>
+        </p:nvSpPr>
+        <p:spPr>
+          <a:xfrm>
+            <a:off x="530352" y="5020056"/>
+            <a:ext cx="11130991" cy="316992"/>
+          </a:xfrm>
+          <a:prstGeom prst="rect">
+            <a:avLst/>
+          </a:prstGeom>
+          <a:noFill/>
+        </p:spPr>
+        <p:txBody>
+          <a:bodyPr wrap="square" anchor="t" lIns="0" rIns="0" tIns="0" bIns="0">
+            <a:spAutoFit/>
+          </a:bodyPr>
+          <a:lstStyle/>
+          <a:p>
+            <a:pPr algn="ctr"/>
+            <a:r>
+              <a:rPr sz="1200" b="0" i="0">
+                <a:solidFill>
+                  <a:srgbClr val="6B6690"/>
+                </a:solidFill>
+                <a:latin typeface="Calibri"/>
+              </a:rPr>
+              <a:t>The average cost of a week's plan against how far it is raised</a:t>
+            </a:r>
+          </a:p>
+        </p:txBody>
+      </p:sp>
+      <p:sp>
+        <p:nvSpPr>
+          <p:cNvPr id="11" name="TextBox 10"/>
+          <p:cNvSpPr txBox="1"/>
+          <p:nvPr/>
+        </p:nvSpPr>
+        <p:spPr>
+          <a:xfrm>
+            <a:off x="530352" y="5346192"/>
+            <a:ext cx="11130991" cy="853440"/>
+          </a:xfrm>
+          <a:prstGeom prst="rect">
+            <a:avLst/>
+          </a:prstGeom>
+          <a:noFill/>
+        </p:spPr>
+        <p:txBody>
+          <a:bodyPr wrap="square" anchor="t" lIns="0" rIns="0" tIns="0" bIns="0">
+            <a:spAutoFit/>
+          </a:bodyPr>
+          <a:lstStyle/>
+          <a:p>
+            <a:r>
+              <a:rPr sz="1400" b="0" i="0">
+                <a:solidFill>
+                  <a:srgbClr val="1A1440"/>
+                </a:solidFill>
+                <a:latin typeface="Calibri"/>
+              </a:rPr>
+              <a:t>The answer is b. Raise the plan by one shipment. Over 100 weeks, if demand beats the plan in 18, that shipment saves 18 x Rs 25 = Rs 450 and wastes 82 x Rs 5.42 = Rs 444: about even. So the cheapest plan covers demand in 25 / (25 + 5.42), about 0.82, of weeks: the newsvendor rule, named after a seller deciding how many newspapers to stock.</a:t>
+            </a:r>
+          </a:p>
+        </p:txBody>
+      </p:sp>
+      <p:sp>
+        <p:nvSpPr>
+          <p:cNvPr id="12" name="TextBox 11"/>
+          <p:cNvSpPr txBox="1"/>
+          <p:nvPr/>
+        </p:nvSpPr>
+        <p:spPr>
+          <a:xfrm>
+            <a:off x="530352" y="6437376"/>
+            <a:ext cx="9667951" cy="160401"/>
+          </a:xfrm>
+          <a:prstGeom prst="rect">
+            <a:avLst/>
+          </a:prstGeom>
+          <a:noFill/>
+        </p:spPr>
+        <p:txBody>
+          <a:bodyPr wrap="square" anchor="t" lIns="0" rIns="0" tIns="0" bIns="0">
+            <a:spAutoFit/>
+          </a:bodyPr>
+          <a:lstStyle/>
+          <a:p>
+            <a:pPr algn="l"/>
+            <a:r>
+              <a:rPr sz="750" b="0" i="0">
+                <a:solidFill>
+                  <a:srgbClr val="6B6690"/>
+                </a:solidFill>
+                <a:latin typeface="Calibri"/>
+              </a:rPr>
+              <a:t>Week 4, Day 5. Forecasting basics: the fallback hour</a:t>
+            </a:r>
+          </a:p>
+        </p:txBody>
+      </p:sp>
+      <p:sp>
+        <p:nvSpPr>
+          <p:cNvPr id="13" name="TextBox 12"/>
+          <p:cNvSpPr txBox="1"/>
+          <p:nvPr/>
+        </p:nvSpPr>
+        <p:spPr>
+          <a:xfrm>
+            <a:off x="10198303" y="6437376"/>
+            <a:ext cx="1463040" cy="160401"/>
+          </a:xfrm>
+          <a:prstGeom prst="rect">
+            <a:avLst/>
+          </a:prstGeom>
+          <a:noFill/>
+        </p:spPr>
+        <p:txBody>
+          <a:bodyPr wrap="square" anchor="t" lIns="0" rIns="0" tIns="0" bIns="0">
+            <a:spAutoFit/>
+          </a:bodyPr>
+          <a:lstStyle/>
+          <a:p>
+            <a:pPr algn="r"/>
+            <a:r>
+              <a:rPr sz="750" b="0" i="0">
+                <a:solidFill>
+                  <a:srgbClr val="6B6690"/>
+                </a:solidFill>
+                <a:latin typeface="Calibri"/>
+              </a:rPr>
+              <a:t>S11  ·  11 / 18</a:t>
+            </a:r>
+          </a:p>
+        </p:txBody>
+      </p:sp>
+    </p:spTree>
+  </p:cSld>
+  <p:clrMapOvr>
+    <a:masterClrMapping/>
+  </p:clrMapOvr>
+</p:sld>
+</file>
+
+<file path=ppt/slides/slide12.xml><?xml version="1.0" encoding="utf-8"?>
+<p:sld xmlns:a="http://schemas.openxmlformats.org/drawingml/2006/main" xmlns:p="http://schemas.openxmlformats.org/presentationml/2006/main" xmlns:r="http://schemas.openxmlformats.org/officeDocument/2006/relationships">
+  <p:cSld>
+    <p:spTree>
+      <p:nvGrpSpPr>
+        <p:cNvPr id="1" name=""/>
+        <p:cNvGrpSpPr/>
+        <p:nvPr/>
+      </p:nvGrpSpPr>
+      <p:grpSpPr/>
+      <p:pic>
+        <p:nvPicPr>
+          <p:cNvPr id="2" name="Picture 1" descr="bg_light.jpg"/>
+          <p:cNvPicPr>
+            <a:picLocks noChangeAspect="1"/>
+          </p:cNvPicPr>
+          <p:nvPr/>
+        </p:nvPicPr>
+        <p:blipFill>
+          <a:blip r:embed="rId2"/>
+          <a:stretch>
+            <a:fillRect/>
+          </a:stretch>
+        </p:blipFill>
+        <p:spPr>
+          <a:xfrm>
+            <a:off x="0" y="0"/>
+            <a:ext cx="12191695" cy="6858000"/>
+          </a:xfrm>
+          <a:prstGeom prst="rect">
+            <a:avLst/>
+          </a:prstGeom>
+        </p:spPr>
+      </p:pic>
+      <p:pic>
+        <p:nvPicPr>
+          <p:cNvPr id="3" name="Picture 2" descr="iitgn_logo.png"/>
+          <p:cNvPicPr>
+            <a:picLocks noChangeAspect="1"/>
+          </p:cNvPicPr>
+          <p:nvPr/>
+        </p:nvPicPr>
+        <p:blipFill>
+          <a:blip r:embed="rId3"/>
+          <a:stretch>
+            <a:fillRect/>
+          </a:stretch>
+        </p:blipFill>
+        <p:spPr>
+          <a:xfrm>
+            <a:off x="530352" y="201168"/>
+            <a:ext cx="420624" cy="420624"/>
+          </a:xfrm>
+          <a:prstGeom prst="rect">
+            <a:avLst/>
+          </a:prstGeom>
+        </p:spPr>
+      </p:pic>
+      <p:sp>
+        <p:nvSpPr>
+          <p:cNvPr id="4" name="TextBox 3"/>
+          <p:cNvSpPr txBox="1"/>
+          <p:nvPr/>
+        </p:nvSpPr>
+        <p:spPr>
+          <a:xfrm>
+            <a:off x="1042416" y="228600"/>
+            <a:ext cx="5120640" cy="185166"/>
+          </a:xfrm>
+          <a:prstGeom prst="rect">
+            <a:avLst/>
+          </a:prstGeom>
+          <a:noFill/>
+        </p:spPr>
+        <p:txBody>
+          <a:bodyPr wrap="square" anchor="t" lIns="0" rIns="0" tIns="0" bIns="0">
+            <a:spAutoFit/>
+          </a:bodyPr>
+          <a:lstStyle/>
+          <a:p>
+            <a:pPr algn="l"/>
+            <a:r>
+              <a:rPr sz="900" b="1" i="0">
+                <a:solidFill>
+                  <a:srgbClr val="1A0F5C"/>
+                </a:solidFill>
+                <a:latin typeface="Calibri"/>
+              </a:rPr>
+              <a:t>Indian Institute of Technology Gandhinagar</a:t>
+            </a:r>
+          </a:p>
+        </p:txBody>
+      </p:sp>
+      <p:sp>
+        <p:nvSpPr>
+          <p:cNvPr id="5" name="TextBox 4"/>
+          <p:cNvSpPr txBox="1"/>
+          <p:nvPr/>
+        </p:nvSpPr>
+        <p:spPr>
+          <a:xfrm>
+            <a:off x="1042416" y="420623"/>
+            <a:ext cx="5852160" cy="127381"/>
+          </a:xfrm>
+          <a:prstGeom prst="rect">
+            <a:avLst/>
+          </a:prstGeom>
+          <a:noFill/>
+        </p:spPr>
+        <p:txBody>
+          <a:bodyPr wrap="square" anchor="t" lIns="0" rIns="0" tIns="0" bIns="0">
+            <a:spAutoFit/>
+          </a:bodyPr>
+          <a:lstStyle/>
+          <a:p>
+            <a:pPr algn="l"/>
+            <a:r>
+              <a:rPr sz="550" b="1" i="0" spc="300">
+                <a:solidFill>
+                  <a:srgbClr val="6B6690"/>
+                </a:solidFill>
+                <a:latin typeface="Calibri"/>
+              </a:rPr>
+              <a:t>ADMINISTERED THROUGH THE COMPETENCY ADVANCEMENT ACADEMY</a:t>
+            </a:r>
+          </a:p>
+        </p:txBody>
+      </p:sp>
+      <p:sp>
+        <p:nvSpPr>
+          <p:cNvPr id="6" name="TextBox 5"/>
+          <p:cNvSpPr txBox="1"/>
+          <p:nvPr/>
+        </p:nvSpPr>
+        <p:spPr>
+          <a:xfrm>
+            <a:off x="5992063" y="310896"/>
+            <a:ext cx="5669280" cy="127381"/>
+          </a:xfrm>
+          <a:prstGeom prst="rect">
+            <a:avLst/>
+          </a:prstGeom>
+          <a:noFill/>
+        </p:spPr>
+        <p:txBody>
+          <a:bodyPr wrap="square" anchor="t" lIns="0" rIns="0" tIns="0" bIns="0">
+            <a:spAutoFit/>
+          </a:bodyPr>
+          <a:lstStyle/>
+          <a:p>
+            <a:pPr algn="r"/>
+            <a:r>
+              <a:rPr sz="550" b="1" i="0" spc="300">
+                <a:solidFill>
+                  <a:srgbClr val="6B6690"/>
+                </a:solidFill>
+                <a:latin typeface="Calibri"/>
+              </a:rPr>
+              <a:t>WEEK 4  ·  FRIDAY  ·  FORECASTING BASICS  ·  FALLBACK</a:t>
+            </a:r>
+          </a:p>
+        </p:txBody>
+      </p:sp>
+      <p:sp>
+        <p:nvSpPr>
+          <p:cNvPr id="7" name="TextBox 6"/>
+          <p:cNvSpPr txBox="1"/>
+          <p:nvPr/>
+        </p:nvSpPr>
+        <p:spPr>
+          <a:xfrm>
+            <a:off x="530352" y="676656"/>
+            <a:ext cx="11130991" cy="512064"/>
+          </a:xfrm>
+          <a:prstGeom prst="rect">
+            <a:avLst/>
+          </a:prstGeom>
+          <a:noFill/>
+        </p:spPr>
+        <p:txBody>
+          <a:bodyPr wrap="square" anchor="b" lIns="0" rIns="0" tIns="0" bIns="0">
+            <a:spAutoFit/>
+          </a:bodyPr>
+          <a:lstStyle/>
+          <a:p>
+            <a:pPr algn="l"/>
+            <a:r>
+              <a:rPr sz="2600" b="0" i="0">
+                <a:solidFill>
+                  <a:srgbClr val="1A0F5C"/>
+                </a:solidFill>
+                <a:latin typeface="Georgia"/>
+              </a:rPr>
+              <a:t>The 2.6 percent sits 0.82 along thirteen weeks</a:t>
+            </a:r>
+          </a:p>
+        </p:txBody>
+      </p:sp>
+      <p:sp>
+        <p:nvSpPr>
+          <p:cNvPr id="8" name="TextBox 7"/>
+          <p:cNvSpPr txBox="1"/>
+          <p:nvPr/>
+        </p:nvSpPr>
+        <p:spPr>
+          <a:xfrm>
+            <a:off x="530352" y="1243584"/>
+            <a:ext cx="11130991" cy="234696"/>
+          </a:xfrm>
+          <a:prstGeom prst="rect">
+            <a:avLst/>
+          </a:prstGeom>
+          <a:noFill/>
+        </p:spPr>
+        <p:txBody>
+          <a:bodyPr wrap="square" anchor="t" lIns="0" rIns="0" tIns="0" bIns="0">
+            <a:spAutoFit/>
+          </a:bodyPr>
+          <a:lstStyle/>
+          <a:p>
+            <a:pPr algn="l"/>
+            <a:r>
+              <a:rPr sz="1200" b="0" i="0">
+                <a:solidFill>
+                  <a:srgbClr val="6B6690"/>
+                </a:solidFill>
+                <a:latin typeface="Calibri"/>
+              </a:rPr>
+              <a:t>How far above the forecast is the 0.82 point, on the weeks we hid?</a:t>
+            </a:r>
+          </a:p>
+        </p:txBody>
+      </p:sp>
+      <p:pic>
+        <p:nvPicPr>
+          <p:cNvPr id="9" name="mermaid diagram" descr="C2_W04_D05_cushion_strip_STUDENT.png"/>
+          <p:cNvPicPr>
+            <a:picLocks noChangeAspect="1"/>
+          </p:cNvPicPr>
+          <p:nvPr/>
+        </p:nvPicPr>
+        <p:blipFill>
+          <a:blip r:embed="rId4"/>
+          <a:stretch>
+            <a:fillRect/>
+          </a:stretch>
+        </p:blipFill>
+        <p:spPr>
+          <a:xfrm>
+            <a:off x="2066094" y="1664208"/>
+            <a:ext cx="8059506" cy="2939288"/>
+          </a:xfrm>
+          <a:prstGeom prst="rect">
+            <a:avLst/>
+          </a:prstGeom>
+        </p:spPr>
+      </p:pic>
+      <p:sp>
+        <p:nvSpPr>
+          <p:cNvPr id="10" name="picture caption"/>
+          <p:cNvSpPr txBox="1"/>
+          <p:nvPr/>
+        </p:nvSpPr>
+        <p:spPr>
+          <a:xfrm>
+            <a:off x="530352" y="4640072"/>
+            <a:ext cx="11130991" cy="316992"/>
+          </a:xfrm>
+          <a:prstGeom prst="rect">
+            <a:avLst/>
+          </a:prstGeom>
+          <a:noFill/>
+        </p:spPr>
+        <p:txBody>
+          <a:bodyPr wrap="square" anchor="t" lIns="0" rIns="0" tIns="0" bIns="0">
+            <a:spAutoFit/>
+          </a:bodyPr>
+          <a:lstStyle/>
+          <a:p>
+            <a:pPr algn="ctr"/>
+            <a:r>
+              <a:rPr sz="1200" b="0" i="0">
+                <a:solidFill>
+                  <a:srgbClr val="6B6690"/>
+                </a:solidFill>
+                <a:latin typeface="Calibri"/>
+              </a:rPr>
+              <a:t>Thirteen hidden weeks sorted by how far demand came above festival-aligned</a:t>
+            </a:r>
+          </a:p>
+        </p:txBody>
+      </p:sp>
+      <p:sp>
+        <p:nvSpPr>
+          <p:cNvPr id="11" name="TextBox 10"/>
+          <p:cNvSpPr txBox="1"/>
+          <p:nvPr/>
+        </p:nvSpPr>
+        <p:spPr>
+          <a:xfrm>
+            <a:off x="530352" y="4966208"/>
+            <a:ext cx="11130991" cy="1233424"/>
+          </a:xfrm>
+          <a:prstGeom prst="rect">
+            <a:avLst/>
+          </a:prstGeom>
+          <a:noFill/>
+        </p:spPr>
+        <p:txBody>
+          <a:bodyPr wrap="square" anchor="t" lIns="0" rIns="0" tIns="0" bIns="0">
+            <a:spAutoFit/>
+          </a:bodyPr>
+          <a:lstStyle/>
+          <a:p>
+            <a:r>
+              <a:rPr sz="1600" b="0" i="0">
+                <a:solidFill>
+                  <a:srgbClr val="1A1440"/>
+                </a:solidFill>
+                <a:latin typeface="Calibri"/>
+              </a:rPr>
+              <a:t>Sort the thirteen hidden weeks by how far demand came above festival-aligned: from 5.9 percent below to 7.8 percent above. The 0.82 point falls between the 10th week, 2.1 percent, and the 11th, 2.7; read 0.82 of the way along, it is 2.6 percent. The raised forecast covers 10 of the 13 weeks, and the 11th sits just above it.</a:t>
+            </a:r>
+          </a:p>
+        </p:txBody>
+      </p:sp>
+      <p:sp>
+        <p:nvSpPr>
+          <p:cNvPr id="12" name="TextBox 11"/>
+          <p:cNvSpPr txBox="1"/>
+          <p:nvPr/>
+        </p:nvSpPr>
+        <p:spPr>
+          <a:xfrm>
+            <a:off x="530352" y="6437376"/>
+            <a:ext cx="9667951" cy="160401"/>
+          </a:xfrm>
+          <a:prstGeom prst="rect">
+            <a:avLst/>
+          </a:prstGeom>
+          <a:noFill/>
+        </p:spPr>
+        <p:txBody>
+          <a:bodyPr wrap="square" anchor="t" lIns="0" rIns="0" tIns="0" bIns="0">
+            <a:spAutoFit/>
+          </a:bodyPr>
+          <a:lstStyle/>
+          <a:p>
+            <a:pPr algn="l"/>
+            <a:r>
+              <a:rPr sz="750" b="0" i="0">
+                <a:solidFill>
+                  <a:srgbClr val="6B6690"/>
+                </a:solidFill>
+                <a:latin typeface="Calibri"/>
+              </a:rPr>
+              <a:t>Week 4, Day 5. Forecasting basics: the fallback hour</a:t>
+            </a:r>
+          </a:p>
+        </p:txBody>
+      </p:sp>
+      <p:sp>
+        <p:nvSpPr>
+          <p:cNvPr id="13" name="TextBox 12"/>
+          <p:cNvSpPr txBox="1"/>
+          <p:nvPr/>
+        </p:nvSpPr>
+        <p:spPr>
+          <a:xfrm>
+            <a:off x="10198303" y="6437376"/>
+            <a:ext cx="1463040" cy="160401"/>
+          </a:xfrm>
+          <a:prstGeom prst="rect">
+            <a:avLst/>
+          </a:prstGeom>
+          <a:noFill/>
+        </p:spPr>
+        <p:txBody>
+          <a:bodyPr wrap="square" anchor="t" lIns="0" rIns="0" tIns="0" bIns="0">
+            <a:spAutoFit/>
+          </a:bodyPr>
+          <a:lstStyle/>
+          <a:p>
+            <a:pPr algn="r"/>
+            <a:r>
+              <a:rPr sz="750" b="0" i="0">
+                <a:solidFill>
+                  <a:srgbClr val="6B6690"/>
+                </a:solidFill>
+                <a:latin typeface="Calibri"/>
+              </a:rPr>
+              <a:t>S12  ·  12 / 18</a:t>
+            </a:r>
+          </a:p>
+        </p:txBody>
+      </p:sp>
+    </p:spTree>
+  </p:cSld>
+  <p:clrMapOvr>
+    <a:masterClrMapping/>
+  </p:clrMapOvr>
+</p:sld>
+</file>
+
+<file path=ppt/slides/slide13.xml><?xml version="1.0" encoding="utf-8"?>
+<p:sld xmlns:a="http://schemas.openxmlformats.org/drawingml/2006/main" xmlns:p="http://schemas.openxmlformats.org/presentationml/2006/main" xmlns:r="http://schemas.openxmlformats.org/officeDocument/2006/relationships">
+  <p:cSld>
+    <p:spTree>
+      <p:nvGrpSpPr>
+        <p:cNvPr id="1" name=""/>
+        <p:cNvGrpSpPr/>
+        <p:nvPr/>
+      </p:nvGrpSpPr>
+      <p:grpSpPr/>
+      <p:pic>
+        <p:nvPicPr>
+          <p:cNvPr id="2" name="Picture 1" descr="bg_light.jpg"/>
+          <p:cNvPicPr>
+            <a:picLocks noChangeAspect="1"/>
+          </p:cNvPicPr>
+          <p:nvPr/>
+        </p:nvPicPr>
+        <p:blipFill>
+          <a:blip r:embed="rId2"/>
+          <a:stretch>
+            <a:fillRect/>
+          </a:stretch>
+        </p:blipFill>
+        <p:spPr>
+          <a:xfrm>
+            <a:off x="0" y="0"/>
+            <a:ext cx="12191695" cy="6858000"/>
+          </a:xfrm>
+          <a:prstGeom prst="rect">
+            <a:avLst/>
+          </a:prstGeom>
+        </p:spPr>
+      </p:pic>
+      <p:pic>
+        <p:nvPicPr>
+          <p:cNvPr id="3" name="Picture 2" descr="iitgn_logo.png"/>
+          <p:cNvPicPr>
+            <a:picLocks noChangeAspect="1"/>
+          </p:cNvPicPr>
+          <p:nvPr/>
+        </p:nvPicPr>
+        <p:blipFill>
+          <a:blip r:embed="rId3"/>
+          <a:stretch>
+            <a:fillRect/>
+          </a:stretch>
+        </p:blipFill>
+        <p:spPr>
+          <a:xfrm>
+            <a:off x="530352" y="201168"/>
+            <a:ext cx="420624" cy="420624"/>
+          </a:xfrm>
+          <a:prstGeom prst="rect">
+            <a:avLst/>
+          </a:prstGeom>
+        </p:spPr>
+      </p:pic>
+      <p:sp>
+        <p:nvSpPr>
+          <p:cNvPr id="4" name="TextBox 3"/>
+          <p:cNvSpPr txBox="1"/>
+          <p:nvPr/>
+        </p:nvSpPr>
+        <p:spPr>
+          <a:xfrm>
+            <a:off x="1042416" y="228600"/>
+            <a:ext cx="5120640" cy="185166"/>
+          </a:xfrm>
+          <a:prstGeom prst="rect">
+            <a:avLst/>
+          </a:prstGeom>
+          <a:noFill/>
+        </p:spPr>
+        <p:txBody>
+          <a:bodyPr wrap="square" anchor="t" lIns="0" rIns="0" tIns="0" bIns="0">
+            <a:spAutoFit/>
+          </a:bodyPr>
+          <a:lstStyle/>
+          <a:p>
+            <a:pPr algn="l"/>
+            <a:r>
+              <a:rPr sz="900" b="1" i="0">
+                <a:solidFill>
+                  <a:srgbClr val="1A0F5C"/>
+                </a:solidFill>
+                <a:latin typeface="Calibri"/>
+              </a:rPr>
+              <a:t>Indian Institute of Technology Gandhinagar</a:t>
+            </a:r>
+          </a:p>
+        </p:txBody>
+      </p:sp>
+      <p:sp>
+        <p:nvSpPr>
+          <p:cNvPr id="5" name="TextBox 4"/>
+          <p:cNvSpPr txBox="1"/>
+          <p:nvPr/>
+        </p:nvSpPr>
+        <p:spPr>
+          <a:xfrm>
+            <a:off x="1042416" y="420623"/>
+            <a:ext cx="5852160" cy="127381"/>
+          </a:xfrm>
+          <a:prstGeom prst="rect">
+            <a:avLst/>
+          </a:prstGeom>
+          <a:noFill/>
+        </p:spPr>
+        <p:txBody>
+          <a:bodyPr wrap="square" anchor="t" lIns="0" rIns="0" tIns="0" bIns="0">
+            <a:spAutoFit/>
+          </a:bodyPr>
+          <a:lstStyle/>
+          <a:p>
+            <a:pPr algn="l"/>
+            <a:r>
+              <a:rPr sz="550" b="1" i="0" spc="300">
+                <a:solidFill>
+                  <a:srgbClr val="6B6690"/>
+                </a:solidFill>
+                <a:latin typeface="Calibri"/>
+              </a:rPr>
+              <a:t>ADMINISTERED THROUGH THE COMPETENCY ADVANCEMENT ACADEMY</a:t>
+            </a:r>
+          </a:p>
+        </p:txBody>
+      </p:sp>
+      <p:sp>
+        <p:nvSpPr>
+          <p:cNvPr id="6" name="TextBox 5"/>
+          <p:cNvSpPr txBox="1"/>
+          <p:nvPr/>
+        </p:nvSpPr>
+        <p:spPr>
+          <a:xfrm>
+            <a:off x="5992063" y="310896"/>
+            <a:ext cx="5669280" cy="127381"/>
+          </a:xfrm>
+          <a:prstGeom prst="rect">
+            <a:avLst/>
+          </a:prstGeom>
+          <a:noFill/>
+        </p:spPr>
+        <p:txBody>
+          <a:bodyPr wrap="square" anchor="t" lIns="0" rIns="0" tIns="0" bIns="0">
+            <a:spAutoFit/>
+          </a:bodyPr>
+          <a:lstStyle/>
+          <a:p>
+            <a:pPr algn="r"/>
+            <a:r>
+              <a:rPr sz="550" b="1" i="0" spc="300">
+                <a:solidFill>
+                  <a:srgbClr val="6B6690"/>
+                </a:solidFill>
+                <a:latin typeface="Calibri"/>
+              </a:rPr>
+              <a:t>WEEK 4  ·  FRIDAY  ·  FORECASTING BASICS  ·  FALLBACK</a:t>
+            </a:r>
+          </a:p>
+        </p:txBody>
+      </p:sp>
+      <p:sp>
+        <p:nvSpPr>
+          <p:cNvPr id="7" name="TextBox 6"/>
+          <p:cNvSpPr txBox="1"/>
+          <p:nvPr/>
+        </p:nvSpPr>
+        <p:spPr>
+          <a:xfrm>
+            <a:off x="530352" y="676656"/>
+            <a:ext cx="11130991" cy="512064"/>
+          </a:xfrm>
+          <a:prstGeom prst="rect">
+            <a:avLst/>
+          </a:prstGeom>
+          <a:noFill/>
+        </p:spPr>
+        <p:txBody>
+          <a:bodyPr wrap="square" anchor="b" lIns="0" rIns="0" tIns="0" bIns="0">
+            <a:spAutoFit/>
+          </a:bodyPr>
+          <a:lstStyle/>
+          <a:p>
+            <a:pPr algn="l"/>
+            <a:r>
+              <a:rPr sz="2600" b="0" i="0">
+                <a:solidFill>
+                  <a:srgbClr val="1A0F5C"/>
+                </a:solidFill>
+                <a:latin typeface="Georgia"/>
+              </a:rPr>
+              <a:t>The plan, raised: 20,275 packer shifts</a:t>
+            </a:r>
+          </a:p>
+        </p:txBody>
+      </p:sp>
+      <p:sp>
+        <p:nvSpPr>
+          <p:cNvPr id="8" name="TextBox 7"/>
+          <p:cNvSpPr txBox="1"/>
+          <p:nvPr/>
+        </p:nvSpPr>
+        <p:spPr>
+          <a:xfrm>
+            <a:off x="530352" y="1243584"/>
+            <a:ext cx="11130991" cy="234696"/>
+          </a:xfrm>
+          <a:prstGeom prst="rect">
+            <a:avLst/>
+          </a:prstGeom>
+          <a:noFill/>
+        </p:spPr>
+        <p:txBody>
+          <a:bodyPr wrap="square" anchor="t" lIns="0" rIns="0" tIns="0" bIns="0">
+            <a:spAutoFit/>
+          </a:bodyPr>
+          <a:lstStyle/>
+          <a:p>
+            <a:pPr algn="l"/>
+            <a:r>
+              <a:rPr sz="1200" b="0" i="0">
+                <a:solidFill>
+                  <a:srgbClr val="6B6690"/>
+                </a:solidFill>
+                <a:latin typeface="Calibri"/>
+              </a:rPr>
+              <a:t>How many packer shifts does each week need once the plan sits 2.6 percent above the forecast?</a:t>
+            </a:r>
+          </a:p>
+        </p:txBody>
+      </p:sp>
+      <p:graphicFrame>
+        <p:nvGraphicFramePr>
+          <p:cNvPr id="9" name="Table 8"/>
+          <p:cNvGraphicFramePr>
+            <a:graphicFrameLocks noGrp="1"/>
+          </p:cNvGraphicFramePr>
+          <p:nvPr/>
+        </p:nvGraphicFramePr>
+        <p:xfrm>
+          <a:off x="530352" y="1682496"/>
+          <a:ext cx="11130990" cy="3017520"/>
+        </p:xfrm>
+        <a:graphic>
+          <a:graphicData uri="http://schemas.openxmlformats.org/drawingml/2006/table">
+            <a:tbl>
+              <a:tblPr firstRow="0" bandRow="0">
+                <a:tableStyleId>{2D5ABB26-0587-4C30-8999-92F81FD0307C}</a:tableStyleId>
+              </a:tblPr>
+              <a:tblGrid>
+                <a:gridCol w="914400"/>
+                <a:gridCol w="2123058"/>
+                <a:gridCol w="4957996"/>
+                <a:gridCol w="3135536"/>
+              </a:tblGrid>
+              <a:tr h="335280">
+                <a:tc>
+                  <a:txBody>
+                    <a:bodyPr/>
+                    <a:lstStyle/>
+                    <a:p>
+                      <a:r>
+                        <a:rPr sz="1250" b="1" i="0">
+                          <a:solidFill>
+                            <a:srgbClr val="FFFFFF"/>
+                          </a:solidFill>
+                          <a:latin typeface="Calibri"/>
+                        </a:rPr>
+                        <a:t>Week of</a:t>
+                      </a:r>
+                    </a:p>
+                  </a:txBody>
+                  <a:tcPr marL="101600" marR="101600" marT="38100" marB="38100" anchor="ctr">
+                    <a:solidFill>
+                      <a:srgbClr val="1A0F5C"/>
+                    </a:solidFill>
+                  </a:tcPr>
+                </a:tc>
+                <a:tc>
+                  <a:txBody>
+                    <a:bodyPr/>
+                    <a:lstStyle/>
+                    <a:p>
+                      <a:r>
+                        <a:rPr sz="1250" b="1" i="0">
+                          <a:solidFill>
+                            <a:srgbClr val="FFFFFF"/>
+                          </a:solidFill>
+                          <a:latin typeface="Calibri"/>
+                        </a:rPr>
+                        <a:t>Forecast</a:t>
+                      </a:r>
+                    </a:p>
+                  </a:txBody>
+                  <a:tcPr marL="101600" marR="101600" marT="38100" marB="38100" anchor="ctr">
+                    <a:solidFill>
+                      <a:srgbClr val="1A0F5C"/>
+                    </a:solidFill>
+                  </a:tcPr>
+                </a:tc>
+                <a:tc>
+                  <a:txBody>
+                    <a:bodyPr/>
+                    <a:lstStyle/>
+                    <a:p>
+                      <a:r>
+                        <a:rPr sz="1250" b="1" i="0">
+                          <a:solidFill>
+                            <a:srgbClr val="FFFFFF"/>
+                          </a:solidFill>
+                          <a:latin typeface="Calibri"/>
+                        </a:rPr>
+                        <a:t>Plan, plus 2.6 percent</a:t>
+                      </a:r>
+                    </a:p>
+                  </a:txBody>
+                  <a:tcPr marL="101600" marR="101600" marT="38100" marB="38100" anchor="ctr">
+                    <a:solidFill>
+                      <a:srgbClr val="1A0F5C"/>
+                    </a:solidFill>
+                  </a:tcPr>
+                </a:tc>
+                <a:tc>
+                  <a:txBody>
+                    <a:bodyPr/>
+                    <a:lstStyle/>
+                    <a:p>
+                      <a:r>
+                        <a:rPr sz="1250" b="1" i="0">
+                          <a:solidFill>
+                            <a:srgbClr val="FFFFFF"/>
+                          </a:solidFill>
+                          <a:latin typeface="Calibri"/>
+                        </a:rPr>
+                        <a:t>Packer shifts</a:t>
+                      </a:r>
+                    </a:p>
+                  </a:txBody>
+                  <a:tcPr marL="101600" marR="101600" marT="38100" marB="38100" anchor="ctr">
+                    <a:solidFill>
+                      <a:srgbClr val="1A0F5C"/>
+                    </a:solidFill>
+                  </a:tcPr>
+                </a:tc>
+              </a:tr>
+              <a:tr h="335280">
+                <a:tc>
+                  <a:txBody>
+                    <a:bodyPr/>
+                    <a:lstStyle/>
+                    <a:p>
+                      <a:r>
+                        <a:rPr sz="1200" b="0" i="0">
+                          <a:solidFill>
+                            <a:srgbClr val="1A1440"/>
+                          </a:solidFill>
+                          <a:latin typeface="Calibri"/>
+                        </a:rPr>
+                        <a:t>12 Oct</a:t>
+                      </a:r>
+                    </a:p>
+                  </a:txBody>
+                  <a:tcPr marL="101600" marR="101600" marT="38100" marB="38100" anchor="ctr">
+                    <a:solidFill>
+                      <a:srgbClr val="FFFFFF"/>
+                    </a:solidFill>
+                  </a:tcPr>
+                </a:tc>
+                <a:tc>
+                  <a:txBody>
+                    <a:bodyPr/>
+                    <a:lstStyle/>
+                    <a:p>
+                      <a:r>
+                        <a:rPr sz="1200" b="0" i="0">
+                          <a:solidFill>
+                            <a:srgbClr val="1A1440"/>
+                          </a:solidFill>
+                          <a:latin typeface="Calibri"/>
+                        </a:rPr>
+                        <a:t>344,448</a:t>
+                      </a:r>
+                    </a:p>
+                  </a:txBody>
+                  <a:tcPr marL="101600" marR="101600" marT="38100" marB="38100" anchor="ctr">
+                    <a:solidFill>
+                      <a:srgbClr val="FFFFFF"/>
+                    </a:solidFill>
+                  </a:tcPr>
+                </a:tc>
+                <a:tc>
+                  <a:txBody>
+                    <a:bodyPr/>
+                    <a:lstStyle/>
+                    <a:p>
+                      <a:r>
+                        <a:rPr sz="1200" b="0" i="0">
+                          <a:solidFill>
+                            <a:srgbClr val="1A1440"/>
+                          </a:solidFill>
+                          <a:latin typeface="Calibri"/>
+                        </a:rPr>
+                        <a:t>353,404</a:t>
+                      </a:r>
+                    </a:p>
+                  </a:txBody>
+                  <a:tcPr marL="101600" marR="101600" marT="38100" marB="38100" anchor="ctr">
+                    <a:solidFill>
+                      <a:srgbClr val="FFFFFF"/>
+                    </a:solidFill>
+                  </a:tcPr>
+                </a:tc>
+                <a:tc>
+                  <a:txBody>
+                    <a:bodyPr/>
+                    <a:lstStyle/>
+                    <a:p>
+                      <a:r>
+                        <a:rPr sz="1200" b="0" i="0">
+                          <a:solidFill>
+                            <a:srgbClr val="1A1440"/>
+                          </a:solidFill>
+                          <a:latin typeface="Calibri"/>
+                        </a:rPr>
+                        <a:t>2,946</a:t>
+                      </a:r>
+                    </a:p>
+                  </a:txBody>
+                  <a:tcPr marL="101600" marR="101600" marT="38100" marB="38100" anchor="ctr">
+                    <a:solidFill>
+                      <a:srgbClr val="FFFFFF"/>
+                    </a:solidFill>
+                  </a:tcPr>
+                </a:tc>
+              </a:tr>
+              <a:tr h="335280">
+                <a:tc>
+                  <a:txBody>
+                    <a:bodyPr/>
+                    <a:lstStyle/>
+                    <a:p>
+                      <a:r>
+                        <a:rPr sz="1200" b="0" i="0">
+                          <a:solidFill>
+                            <a:srgbClr val="1A1440"/>
+                          </a:solidFill>
+                          <a:latin typeface="Calibri"/>
+                        </a:rPr>
+                        <a:t>19 Oct</a:t>
+                      </a:r>
+                    </a:p>
+                  </a:txBody>
+                  <a:tcPr marL="101600" marR="101600" marT="38100" marB="38100" anchor="ctr">
+                    <a:solidFill>
+                      <a:srgbClr val="F4F2FA"/>
+                    </a:solidFill>
+                  </a:tcPr>
+                </a:tc>
+                <a:tc>
+                  <a:txBody>
+                    <a:bodyPr/>
+                    <a:lstStyle/>
+                    <a:p>
+                      <a:r>
+                        <a:rPr sz="1200" b="0" i="0">
+                          <a:solidFill>
+                            <a:srgbClr val="1A1440"/>
+                          </a:solidFill>
+                          <a:latin typeface="Calibri"/>
+                        </a:rPr>
+                        <a:t>434,928</a:t>
+                      </a:r>
+                    </a:p>
+                  </a:txBody>
+                  <a:tcPr marL="101600" marR="101600" marT="38100" marB="38100" anchor="ctr">
+                    <a:solidFill>
+                      <a:srgbClr val="F4F2FA"/>
+                    </a:solidFill>
+                  </a:tcPr>
+                </a:tc>
+                <a:tc>
+                  <a:txBody>
+                    <a:bodyPr/>
+                    <a:lstStyle/>
+                    <a:p>
+                      <a:r>
+                        <a:rPr sz="1200" b="0" i="0">
+                          <a:solidFill>
+                            <a:srgbClr val="1A1440"/>
+                          </a:solidFill>
+                          <a:latin typeface="Calibri"/>
+                        </a:rPr>
+                        <a:t>446,236</a:t>
+                      </a:r>
+                    </a:p>
+                  </a:txBody>
+                  <a:tcPr marL="101600" marR="101600" marT="38100" marB="38100" anchor="ctr">
+                    <a:solidFill>
+                      <a:srgbClr val="F4F2FA"/>
+                    </a:solidFill>
+                  </a:tcPr>
+                </a:tc>
+                <a:tc>
+                  <a:txBody>
+                    <a:bodyPr/>
+                    <a:lstStyle/>
+                    <a:p>
+                      <a:r>
+                        <a:rPr sz="1200" b="0" i="0">
+                          <a:solidFill>
+                            <a:srgbClr val="1A1440"/>
+                          </a:solidFill>
+                          <a:latin typeface="Calibri"/>
+                        </a:rPr>
+                        <a:t>3,719</a:t>
+                      </a:r>
+                    </a:p>
+                  </a:txBody>
+                  <a:tcPr marL="101600" marR="101600" marT="38100" marB="38100" anchor="ctr">
+                    <a:solidFill>
+                      <a:srgbClr val="F4F2FA"/>
+                    </a:solidFill>
+                  </a:tcPr>
+                </a:tc>
+              </a:tr>
+              <a:tr h="335280">
+                <a:tc>
+                  <a:txBody>
+                    <a:bodyPr/>
+                    <a:lstStyle/>
+                    <a:p>
+                      <a:r>
+                        <a:rPr sz="1200" b="0" i="0">
+                          <a:solidFill>
+                            <a:srgbClr val="1A1440"/>
+                          </a:solidFill>
+                          <a:latin typeface="Calibri"/>
+                        </a:rPr>
+                        <a:t>26 Oct</a:t>
+                      </a:r>
+                    </a:p>
+                  </a:txBody>
+                  <a:tcPr marL="101600" marR="101600" marT="38100" marB="38100" anchor="ctr">
+                    <a:solidFill>
+                      <a:srgbClr val="FFFFFF"/>
+                    </a:solidFill>
+                  </a:tcPr>
+                </a:tc>
+                <a:tc>
+                  <a:txBody>
+                    <a:bodyPr/>
+                    <a:lstStyle/>
+                    <a:p>
+                      <a:r>
+                        <a:rPr sz="1200" b="0" i="0">
+                          <a:solidFill>
+                            <a:srgbClr val="1A1440"/>
+                          </a:solidFill>
+                          <a:latin typeface="Calibri"/>
+                        </a:rPr>
+                        <a:t>383,760</a:t>
+                      </a:r>
+                    </a:p>
+                  </a:txBody>
+                  <a:tcPr marL="101600" marR="101600" marT="38100" marB="38100" anchor="ctr">
+                    <a:solidFill>
+                      <a:srgbClr val="FFFFFF"/>
+                    </a:solidFill>
+                  </a:tcPr>
+                </a:tc>
+                <a:tc>
+                  <a:txBody>
+                    <a:bodyPr/>
+                    <a:lstStyle/>
+                    <a:p>
+                      <a:r>
+                        <a:rPr sz="1200" b="0" i="0">
+                          <a:solidFill>
+                            <a:srgbClr val="1A1440"/>
+                          </a:solidFill>
+                          <a:latin typeface="Calibri"/>
+                        </a:rPr>
+                        <a:t>393,738</a:t>
+                      </a:r>
+                    </a:p>
+                  </a:txBody>
+                  <a:tcPr marL="101600" marR="101600" marT="38100" marB="38100" anchor="ctr">
+                    <a:solidFill>
+                      <a:srgbClr val="FFFFFF"/>
+                    </a:solidFill>
+                  </a:tcPr>
+                </a:tc>
+                <a:tc>
+                  <a:txBody>
+                    <a:bodyPr/>
+                    <a:lstStyle/>
+                    <a:p>
+                      <a:r>
+                        <a:rPr sz="1200" b="0" i="0">
+                          <a:solidFill>
+                            <a:srgbClr val="1A1440"/>
+                          </a:solidFill>
+                          <a:latin typeface="Calibri"/>
+                        </a:rPr>
+                        <a:t>3,282</a:t>
+                      </a:r>
+                    </a:p>
+                  </a:txBody>
+                  <a:tcPr marL="101600" marR="101600" marT="38100" marB="38100" anchor="ctr">
+                    <a:solidFill>
+                      <a:srgbClr val="FFFFFF"/>
+                    </a:solidFill>
+                  </a:tcPr>
+                </a:tc>
+              </a:tr>
+              <a:tr h="335280">
+                <a:tc>
+                  <a:txBody>
+                    <a:bodyPr/>
+                    <a:lstStyle/>
+                    <a:p>
+                      <a:r>
+                        <a:rPr sz="1200" b="0" i="0">
+                          <a:solidFill>
+                            <a:srgbClr val="1A1440"/>
+                          </a:solidFill>
+                          <a:latin typeface="Calibri"/>
+                        </a:rPr>
+                        <a:t>2 Nov</a:t>
+                      </a:r>
+                    </a:p>
+                  </a:txBody>
+                  <a:tcPr marL="101600" marR="101600" marT="38100" marB="38100" anchor="ctr">
+                    <a:solidFill>
+                      <a:srgbClr val="F4F2FA"/>
+                    </a:solidFill>
+                  </a:tcPr>
+                </a:tc>
+                <a:tc>
+                  <a:txBody>
+                    <a:bodyPr/>
+                    <a:lstStyle/>
+                    <a:p>
+                      <a:r>
+                        <a:rPr sz="1200" b="0" i="0">
+                          <a:solidFill>
+                            <a:srgbClr val="1A1440"/>
+                          </a:solidFill>
+                          <a:latin typeface="Calibri"/>
+                        </a:rPr>
+                        <a:t>321,256</a:t>
+                      </a:r>
+                    </a:p>
+                  </a:txBody>
+                  <a:tcPr marL="101600" marR="101600" marT="38100" marB="38100" anchor="ctr">
+                    <a:solidFill>
+                      <a:srgbClr val="F4F2FA"/>
+                    </a:solidFill>
+                  </a:tcPr>
+                </a:tc>
+                <a:tc>
+                  <a:txBody>
+                    <a:bodyPr/>
+                    <a:lstStyle/>
+                    <a:p>
+                      <a:r>
+                        <a:rPr sz="1200" b="0" i="0">
+                          <a:solidFill>
+                            <a:srgbClr val="1A1440"/>
+                          </a:solidFill>
+                          <a:latin typeface="Calibri"/>
+                        </a:rPr>
+                        <a:t>329,609</a:t>
+                      </a:r>
+                    </a:p>
+                  </a:txBody>
+                  <a:tcPr marL="101600" marR="101600" marT="38100" marB="38100" anchor="ctr">
+                    <a:solidFill>
+                      <a:srgbClr val="F4F2FA"/>
+                    </a:solidFill>
+                  </a:tcPr>
+                </a:tc>
+                <a:tc>
+                  <a:txBody>
+                    <a:bodyPr/>
+                    <a:lstStyle/>
+                    <a:p>
+                      <a:r>
+                        <a:rPr sz="1200" b="0" i="0">
+                          <a:solidFill>
+                            <a:srgbClr val="1A1440"/>
+                          </a:solidFill>
+                          <a:latin typeface="Calibri"/>
+                        </a:rPr>
+                        <a:t>2,747</a:t>
+                      </a:r>
+                    </a:p>
+                  </a:txBody>
+                  <a:tcPr marL="101600" marR="101600" marT="38100" marB="38100" anchor="ctr">
+                    <a:solidFill>
+                      <a:srgbClr val="F4F2FA"/>
+                    </a:solidFill>
+                  </a:tcPr>
+                </a:tc>
+              </a:tr>
+              <a:tr h="335280">
+                <a:tc>
+                  <a:txBody>
+                    <a:bodyPr/>
+                    <a:lstStyle/>
+                    <a:p>
+                      <a:r>
+                        <a:rPr sz="1200" b="0" i="0">
+                          <a:solidFill>
+                            <a:srgbClr val="1A1440"/>
+                          </a:solidFill>
+                          <a:latin typeface="Calibri"/>
+                        </a:rPr>
+                        <a:t>9 Nov</a:t>
+                      </a:r>
+                    </a:p>
+                  </a:txBody>
+                  <a:tcPr marL="101600" marR="101600" marT="38100" marB="38100" anchor="ctr">
+                    <a:solidFill>
+                      <a:srgbClr val="FFFFFF"/>
+                    </a:solidFill>
+                  </a:tcPr>
+                </a:tc>
+                <a:tc>
+                  <a:txBody>
+                    <a:bodyPr/>
+                    <a:lstStyle/>
+                    <a:p>
+                      <a:r>
+                        <a:rPr sz="1200" b="0" i="0">
+                          <a:solidFill>
+                            <a:srgbClr val="1A1440"/>
+                          </a:solidFill>
+                          <a:latin typeface="Calibri"/>
+                        </a:rPr>
+                        <a:t>196,144</a:t>
+                      </a:r>
+                    </a:p>
+                  </a:txBody>
+                  <a:tcPr marL="101600" marR="101600" marT="38100" marB="38100" anchor="ctr">
+                    <a:solidFill>
+                      <a:srgbClr val="FFFFFF"/>
+                    </a:solidFill>
+                  </a:tcPr>
+                </a:tc>
+                <a:tc>
+                  <a:txBody>
+                    <a:bodyPr/>
+                    <a:lstStyle/>
+                    <a:p>
+                      <a:r>
+                        <a:rPr sz="1200" b="0" i="0">
+                          <a:solidFill>
+                            <a:srgbClr val="1A1440"/>
+                          </a:solidFill>
+                          <a:latin typeface="Calibri"/>
+                        </a:rPr>
+                        <a:t>201,244</a:t>
+                      </a:r>
+                    </a:p>
+                  </a:txBody>
+                  <a:tcPr marL="101600" marR="101600" marT="38100" marB="38100" anchor="ctr">
+                    <a:solidFill>
+                      <a:srgbClr val="FFFFFF"/>
+                    </a:solidFill>
+                  </a:tcPr>
+                </a:tc>
+                <a:tc>
+                  <a:txBody>
+                    <a:bodyPr/>
+                    <a:lstStyle/>
+                    <a:p>
+                      <a:r>
+                        <a:rPr sz="1200" b="0" i="0">
+                          <a:solidFill>
+                            <a:srgbClr val="1A1440"/>
+                          </a:solidFill>
+                          <a:latin typeface="Calibri"/>
+                        </a:rPr>
+                        <a:t>1,678</a:t>
+                      </a:r>
+                    </a:p>
+                  </a:txBody>
+                  <a:tcPr marL="101600" marR="101600" marT="38100" marB="38100" anchor="ctr">
+                    <a:solidFill>
+                      <a:srgbClr val="FFFFFF"/>
+                    </a:solidFill>
+                  </a:tcPr>
+                </a:tc>
+              </a:tr>
+              <a:tr h="335280">
+                <a:tc>
+                  <a:txBody>
+                    <a:bodyPr/>
+                    <a:lstStyle/>
+                    <a:p>
+                      <a:r>
+                        <a:rPr sz="1200" b="0" i="0">
+                          <a:solidFill>
+                            <a:srgbClr val="1A1440"/>
+                          </a:solidFill>
+                          <a:latin typeface="Calibri"/>
+                        </a:rPr>
+                        <a:t>16 Nov</a:t>
+                      </a:r>
+                    </a:p>
+                  </a:txBody>
+                  <a:tcPr marL="101600" marR="101600" marT="38100" marB="38100" anchor="ctr">
+                    <a:solidFill>
+                      <a:srgbClr val="F4F2FA"/>
+                    </a:solidFill>
+                  </a:tcPr>
+                </a:tc>
+                <a:tc>
+                  <a:txBody>
+                    <a:bodyPr/>
+                    <a:lstStyle/>
+                    <a:p>
+                      <a:r>
+                        <a:rPr sz="1200" b="0" i="0">
+                          <a:solidFill>
+                            <a:srgbClr val="1A1440"/>
+                          </a:solidFill>
+                          <a:latin typeface="Calibri"/>
+                        </a:rPr>
+                        <a:t>237,016</a:t>
+                      </a:r>
+                    </a:p>
+                  </a:txBody>
+                  <a:tcPr marL="101600" marR="101600" marT="38100" marB="38100" anchor="ctr">
+                    <a:solidFill>
+                      <a:srgbClr val="F4F2FA"/>
+                    </a:solidFill>
+                  </a:tcPr>
+                </a:tc>
+                <a:tc>
+                  <a:txBody>
+                    <a:bodyPr/>
+                    <a:lstStyle/>
+                    <a:p>
+                      <a:r>
+                        <a:rPr sz="1200" b="0" i="0">
+                          <a:solidFill>
+                            <a:srgbClr val="1A1440"/>
+                          </a:solidFill>
+                          <a:latin typeface="Calibri"/>
+                        </a:rPr>
+                        <a:t>243,178</a:t>
+                      </a:r>
+                    </a:p>
+                  </a:txBody>
+                  <a:tcPr marL="101600" marR="101600" marT="38100" marB="38100" anchor="ctr">
+                    <a:solidFill>
+                      <a:srgbClr val="F4F2FA"/>
+                    </a:solidFill>
+                  </a:tcPr>
+                </a:tc>
+                <a:tc>
+                  <a:txBody>
+                    <a:bodyPr/>
+                    <a:lstStyle/>
+                    <a:p>
+                      <a:r>
+                        <a:rPr sz="1200" b="0" i="0">
+                          <a:solidFill>
+                            <a:srgbClr val="1A1440"/>
+                          </a:solidFill>
+                          <a:latin typeface="Calibri"/>
+                        </a:rPr>
+                        <a:t>2,027</a:t>
+                      </a:r>
+                    </a:p>
+                  </a:txBody>
+                  <a:tcPr marL="101600" marR="101600" marT="38100" marB="38100" anchor="ctr">
+                    <a:solidFill>
+                      <a:srgbClr val="F4F2FA"/>
+                    </a:solidFill>
+                  </a:tcPr>
+                </a:tc>
+              </a:tr>
+              <a:tr h="335280">
+                <a:tc>
+                  <a:txBody>
+                    <a:bodyPr/>
+                    <a:lstStyle/>
+                    <a:p>
+                      <a:r>
+                        <a:rPr sz="1200" b="0" i="0">
+                          <a:solidFill>
+                            <a:srgbClr val="1A1440"/>
+                          </a:solidFill>
+                          <a:latin typeface="Calibri"/>
+                        </a:rPr>
+                        <a:t>23 Nov</a:t>
+                      </a:r>
+                    </a:p>
+                  </a:txBody>
+                  <a:tcPr marL="101600" marR="101600" marT="38100" marB="38100" anchor="ctr">
+                    <a:solidFill>
+                      <a:srgbClr val="FFFFFF"/>
+                    </a:solidFill>
+                  </a:tcPr>
+                </a:tc>
+                <a:tc>
+                  <a:txBody>
+                    <a:bodyPr/>
+                    <a:lstStyle/>
+                    <a:p>
+                      <a:r>
+                        <a:rPr sz="1200" b="0" i="0">
+                          <a:solidFill>
+                            <a:srgbClr val="1A1440"/>
+                          </a:solidFill>
+                          <a:latin typeface="Calibri"/>
+                        </a:rPr>
+                        <a:t>225,992</a:t>
+                      </a:r>
+                    </a:p>
+                  </a:txBody>
+                  <a:tcPr marL="101600" marR="101600" marT="38100" marB="38100" anchor="ctr">
+                    <a:solidFill>
+                      <a:srgbClr val="FFFFFF"/>
+                    </a:solidFill>
+                  </a:tcPr>
+                </a:tc>
+                <a:tc>
+                  <a:txBody>
+                    <a:bodyPr/>
+                    <a:lstStyle/>
+                    <a:p>
+                      <a:r>
+                        <a:rPr sz="1200" b="0" i="0">
+                          <a:solidFill>
+                            <a:srgbClr val="1A1440"/>
+                          </a:solidFill>
+                          <a:latin typeface="Calibri"/>
+                        </a:rPr>
+                        <a:t>231,868</a:t>
+                      </a:r>
+                    </a:p>
+                  </a:txBody>
+                  <a:tcPr marL="101600" marR="101600" marT="38100" marB="38100" anchor="ctr">
+                    <a:solidFill>
+                      <a:srgbClr val="FFFFFF"/>
+                    </a:solidFill>
+                  </a:tcPr>
+                </a:tc>
+                <a:tc>
+                  <a:txBody>
+                    <a:bodyPr/>
+                    <a:lstStyle/>
+                    <a:p>
+                      <a:r>
+                        <a:rPr sz="1200" b="0" i="0">
+                          <a:solidFill>
+                            <a:srgbClr val="1A1440"/>
+                          </a:solidFill>
+                          <a:latin typeface="Calibri"/>
+                        </a:rPr>
+                        <a:t>1,933</a:t>
+                      </a:r>
+                    </a:p>
+                  </a:txBody>
+                  <a:tcPr marL="101600" marR="101600" marT="38100" marB="38100" anchor="ctr">
+                    <a:solidFill>
+                      <a:srgbClr val="FFFFFF"/>
+                    </a:solidFill>
+                  </a:tcPr>
+                </a:tc>
+              </a:tr>
+              <a:tr h="335280">
+                <a:tc>
+                  <a:txBody>
+                    <a:bodyPr/>
+                    <a:lstStyle/>
+                    <a:p>
+                      <a:r>
+                        <a:rPr sz="1200" b="0" i="0">
+                          <a:solidFill>
+                            <a:srgbClr val="1A1440"/>
+                          </a:solidFill>
+                          <a:latin typeface="Calibri"/>
+                        </a:rPr>
+                        <a:t>30 Nov</a:t>
+                      </a:r>
+                    </a:p>
+                  </a:txBody>
+                  <a:tcPr marL="101600" marR="101600" marT="38100" marB="38100" anchor="ctr">
+                    <a:solidFill>
+                      <a:srgbClr val="F4F2FA"/>
+                    </a:solidFill>
+                  </a:tcPr>
+                </a:tc>
+                <a:tc>
+                  <a:txBody>
+                    <a:bodyPr/>
+                    <a:lstStyle/>
+                    <a:p>
+                      <a:r>
+                        <a:rPr sz="1200" b="0" i="0">
+                          <a:solidFill>
+                            <a:srgbClr val="1A1440"/>
+                          </a:solidFill>
+                          <a:latin typeface="Calibri"/>
+                        </a:rPr>
+                        <a:t>227,136</a:t>
+                      </a:r>
+                    </a:p>
+                  </a:txBody>
+                  <a:tcPr marL="101600" marR="101600" marT="38100" marB="38100" anchor="ctr">
+                    <a:solidFill>
+                      <a:srgbClr val="F4F2FA"/>
+                    </a:solidFill>
+                  </a:tcPr>
+                </a:tc>
+                <a:tc>
+                  <a:txBody>
+                    <a:bodyPr/>
+                    <a:lstStyle/>
+                    <a:p>
+                      <a:r>
+                        <a:rPr sz="1200" b="0" i="0">
+                          <a:solidFill>
+                            <a:srgbClr val="1A1440"/>
+                          </a:solidFill>
+                          <a:latin typeface="Calibri"/>
+                        </a:rPr>
+                        <a:t>233,042</a:t>
+                      </a:r>
+                    </a:p>
+                  </a:txBody>
+                  <a:tcPr marL="101600" marR="101600" marT="38100" marB="38100" anchor="ctr">
+                    <a:solidFill>
+                      <a:srgbClr val="F4F2FA"/>
+                    </a:solidFill>
+                  </a:tcPr>
+                </a:tc>
+                <a:tc>
+                  <a:txBody>
+                    <a:bodyPr/>
+                    <a:lstStyle/>
+                    <a:p>
+                      <a:r>
+                        <a:rPr sz="1200" b="0" i="0">
+                          <a:solidFill>
+                            <a:srgbClr val="1A1440"/>
+                          </a:solidFill>
+                          <a:latin typeface="Calibri"/>
+                        </a:rPr>
+                        <a:t>1,943</a:t>
+                      </a:r>
+                    </a:p>
+                  </a:txBody>
+                  <a:tcPr marL="101600" marR="101600" marT="38100" marB="38100" anchor="ctr">
+                    <a:solidFill>
+                      <a:srgbClr val="F4F2FA"/>
+                    </a:solidFill>
+                  </a:tcPr>
+                </a:tc>
+              </a:tr>
+            </a:tbl>
+          </a:graphicData>
+        </a:graphic>
+      </p:graphicFrame>
+      <p:sp>
+        <p:nvSpPr>
+          <p:cNvPr id="10" name="TextBox 9"/>
+          <p:cNvSpPr txBox="1"/>
+          <p:nvPr/>
+        </p:nvSpPr>
+        <p:spPr>
+          <a:xfrm>
+            <a:off x="530352" y="4956048"/>
+            <a:ext cx="11130991" cy="1048512"/>
+          </a:xfrm>
+          <a:prstGeom prst="rect">
+            <a:avLst/>
+          </a:prstGeom>
+          <a:noFill/>
+        </p:spPr>
+        <p:txBody>
+          <a:bodyPr wrap="square" anchor="t" lIns="0" rIns="0" tIns="0" bIns="0">
+            <a:spAutoFit/>
+          </a:bodyPr>
+          <a:lstStyle/>
+          <a:p>
+            <a:pPr>
+              <a:spcAft>
+                <a:spcPts val="800"/>
+              </a:spcAft>
+            </a:pPr>
+            <a:r>
+              <a:rPr sz="1600" b="0" i="0">
+                <a:solidFill>
+                  <a:srgbClr val="1A1440"/>
+                </a:solidFill>
+                <a:latin typeface="Calibri"/>
+              </a:rPr>
+              <a:t>Shifts are the plan over 120, rounded up: 20,275 in all, 515 more than the 19,760 the forecast alone needs. For 19 October, demand at the hidden weeks' extremes would need 3,413 to 3,906 shifts against the 3,719 booked.</a:t>
+            </a:r>
+          </a:p>
+        </p:txBody>
+      </p:sp>
+      <p:sp>
+        <p:nvSpPr>
+          <p:cNvPr id="11" name="TextBox 10"/>
+          <p:cNvSpPr txBox="1"/>
+          <p:nvPr/>
+        </p:nvSpPr>
+        <p:spPr>
+          <a:xfrm>
+            <a:off x="530352" y="6437376"/>
+            <a:ext cx="9667951" cy="160401"/>
+          </a:xfrm>
+          <a:prstGeom prst="rect">
+            <a:avLst/>
+          </a:prstGeom>
+          <a:noFill/>
+        </p:spPr>
+        <p:txBody>
+          <a:bodyPr wrap="square" anchor="t" lIns="0" rIns="0" tIns="0" bIns="0">
+            <a:spAutoFit/>
+          </a:bodyPr>
+          <a:lstStyle/>
+          <a:p>
+            <a:pPr algn="l"/>
+            <a:r>
+              <a:rPr sz="750" b="0" i="0">
+                <a:solidFill>
+                  <a:srgbClr val="6B6690"/>
+                </a:solidFill>
+                <a:latin typeface="Calibri"/>
+              </a:rPr>
+              <a:t>Week 4, Day 5. Forecasting basics: the fallback hour</a:t>
+            </a:r>
+          </a:p>
+        </p:txBody>
+      </p:sp>
+      <p:sp>
+        <p:nvSpPr>
+          <p:cNvPr id="12" name="TextBox 11"/>
+          <p:cNvSpPr txBox="1"/>
+          <p:nvPr/>
+        </p:nvSpPr>
+        <p:spPr>
+          <a:xfrm>
+            <a:off x="10198303" y="6437376"/>
+            <a:ext cx="1463040" cy="160401"/>
+          </a:xfrm>
+          <a:prstGeom prst="rect">
+            <a:avLst/>
+          </a:prstGeom>
+          <a:noFill/>
+        </p:spPr>
+        <p:txBody>
+          <a:bodyPr wrap="square" anchor="t" lIns="0" rIns="0" tIns="0" bIns="0">
+            <a:spAutoFit/>
+          </a:bodyPr>
+          <a:lstStyle/>
+          <a:p>
+            <a:pPr algn="r"/>
+            <a:r>
+              <a:rPr sz="750" b="0" i="0">
+                <a:solidFill>
+                  <a:srgbClr val="6B6690"/>
+                </a:solidFill>
+                <a:latin typeface="Calibri"/>
+              </a:rPr>
+              <a:t>S13  ·  13 / 18</a:t>
+            </a:r>
+          </a:p>
+        </p:txBody>
+      </p:sp>
+    </p:spTree>
+  </p:cSld>
+  <p:clrMapOvr>
+    <a:masterClrMapping/>
+  </p:clrMapOvr>
+</p:sld>
+</file>
+
+<file path=ppt/slides/slide14.xml><?xml version="1.0" encoding="utf-8"?>
+<p:sld xmlns:a="http://schemas.openxmlformats.org/drawingml/2006/main" xmlns:p="http://schemas.openxmlformats.org/presentationml/2006/main" xmlns:r="http://schemas.openxmlformats.org/officeDocument/2006/relationships">
+  <p:cSld>
+    <p:spTree>
+      <p:nvGrpSpPr>
+        <p:cNvPr id="1" name=""/>
+        <p:cNvGrpSpPr/>
+        <p:nvPr/>
+      </p:nvGrpSpPr>
+      <p:grpSpPr/>
+      <p:pic>
+        <p:nvPicPr>
+          <p:cNvPr id="2" name="Picture 1" descr="bg_light.jpg"/>
+          <p:cNvPicPr>
+            <a:picLocks noChangeAspect="1"/>
+          </p:cNvPicPr>
+          <p:nvPr/>
+        </p:nvPicPr>
+        <p:blipFill>
+          <a:blip r:embed="rId2"/>
+          <a:stretch>
+            <a:fillRect/>
+          </a:stretch>
+        </p:blipFill>
+        <p:spPr>
+          <a:xfrm>
+            <a:off x="0" y="0"/>
+            <a:ext cx="12191695" cy="6858000"/>
+          </a:xfrm>
+          <a:prstGeom prst="rect">
+            <a:avLst/>
+          </a:prstGeom>
+        </p:spPr>
+      </p:pic>
+      <p:pic>
+        <p:nvPicPr>
+          <p:cNvPr id="3" name="Picture 2" descr="iitgn_logo.png"/>
+          <p:cNvPicPr>
+            <a:picLocks noChangeAspect="1"/>
+          </p:cNvPicPr>
+          <p:nvPr/>
+        </p:nvPicPr>
+        <p:blipFill>
+          <a:blip r:embed="rId3"/>
+          <a:stretch>
+            <a:fillRect/>
+          </a:stretch>
+        </p:blipFill>
+        <p:spPr>
+          <a:xfrm>
+            <a:off x="530352" y="201168"/>
+            <a:ext cx="420624" cy="420624"/>
+          </a:xfrm>
+          <a:prstGeom prst="rect">
+            <a:avLst/>
+          </a:prstGeom>
+        </p:spPr>
+      </p:pic>
+      <p:sp>
+        <p:nvSpPr>
+          <p:cNvPr id="4" name="TextBox 3"/>
+          <p:cNvSpPr txBox="1"/>
+          <p:nvPr/>
+        </p:nvSpPr>
+        <p:spPr>
+          <a:xfrm>
+            <a:off x="1042416" y="228600"/>
+            <a:ext cx="5120640" cy="185166"/>
+          </a:xfrm>
+          <a:prstGeom prst="rect">
+            <a:avLst/>
+          </a:prstGeom>
+          <a:noFill/>
+        </p:spPr>
+        <p:txBody>
+          <a:bodyPr wrap="square" anchor="t" lIns="0" rIns="0" tIns="0" bIns="0">
+            <a:spAutoFit/>
+          </a:bodyPr>
+          <a:lstStyle/>
+          <a:p>
+            <a:pPr algn="l"/>
+            <a:r>
+              <a:rPr sz="900" b="1" i="0">
+                <a:solidFill>
+                  <a:srgbClr val="1A0F5C"/>
+                </a:solidFill>
+                <a:latin typeface="Calibri"/>
+              </a:rPr>
+              <a:t>Indian Institute of Technology Gandhinagar</a:t>
+            </a:r>
+          </a:p>
+        </p:txBody>
+      </p:sp>
+      <p:sp>
+        <p:nvSpPr>
+          <p:cNvPr id="5" name="TextBox 4"/>
+          <p:cNvSpPr txBox="1"/>
+          <p:nvPr/>
+        </p:nvSpPr>
+        <p:spPr>
+          <a:xfrm>
+            <a:off x="1042416" y="420623"/>
+            <a:ext cx="5852160" cy="127381"/>
+          </a:xfrm>
+          <a:prstGeom prst="rect">
+            <a:avLst/>
+          </a:prstGeom>
+          <a:noFill/>
+        </p:spPr>
+        <p:txBody>
+          <a:bodyPr wrap="square" anchor="t" lIns="0" rIns="0" tIns="0" bIns="0">
+            <a:spAutoFit/>
+          </a:bodyPr>
+          <a:lstStyle/>
+          <a:p>
+            <a:pPr algn="l"/>
+            <a:r>
+              <a:rPr sz="550" b="1" i="0" spc="300">
+                <a:solidFill>
+                  <a:srgbClr val="6B6690"/>
+                </a:solidFill>
+                <a:latin typeface="Calibri"/>
+              </a:rPr>
+              <a:t>ADMINISTERED THROUGH THE COMPETENCY ADVANCEMENT ACADEMY</a:t>
+            </a:r>
+          </a:p>
+        </p:txBody>
+      </p:sp>
+      <p:sp>
+        <p:nvSpPr>
+          <p:cNvPr id="6" name="TextBox 5"/>
+          <p:cNvSpPr txBox="1"/>
+          <p:nvPr/>
+        </p:nvSpPr>
+        <p:spPr>
+          <a:xfrm>
+            <a:off x="5992063" y="310896"/>
+            <a:ext cx="5669280" cy="127381"/>
+          </a:xfrm>
+          <a:prstGeom prst="rect">
+            <a:avLst/>
+          </a:prstGeom>
+          <a:noFill/>
+        </p:spPr>
+        <p:txBody>
+          <a:bodyPr wrap="square" anchor="t" lIns="0" rIns="0" tIns="0" bIns="0">
+            <a:spAutoFit/>
+          </a:bodyPr>
+          <a:lstStyle/>
+          <a:p>
+            <a:pPr algn="r"/>
+            <a:r>
+              <a:rPr sz="550" b="1" i="0" spc="300">
+                <a:solidFill>
+                  <a:srgbClr val="6B6690"/>
+                </a:solidFill>
+                <a:latin typeface="Calibri"/>
+              </a:rPr>
+              <a:t>WEEK 4  ·  FRIDAY  ·  FORECASTING BASICS  ·  FALLBACK</a:t>
             </a:r>
           </a:p>
         </p:txBody>
@@ -5399,7 +8997,7 @@
                 </a:solidFill>
                 <a:latin typeface="Calibri"/>
               </a:rPr>
-              <a:t>Week 4 Day 5: how much is coming, and how wrong could we be</a:t>
+              <a:t>Week 4, Day 5. Forecasting basics: the fallback hour</a:t>
             </a:r>
           </a:p>
         </p:txBody>
@@ -5434,7 +9032,7 @@
                 </a:solidFill>
                 <a:latin typeface="Calibri"/>
               </a:rPr>
-              <a:t>S10  ·  10 / 14</a:t>
+              <a:t>S14  ·  14 / 18</a:t>
             </a:r>
           </a:p>
         </p:txBody>
@@ -5447,7 +9045,7 @@
 </p:sld>
 </file>
 
-<file path=ppt/slides/slide11.xml><?xml version="1.0" encoding="utf-8"?>
+<file path=ppt/slides/slide15.xml><?xml version="1.0" encoding="utf-8"?>
 <p:sld xmlns:a="http://schemas.openxmlformats.org/drawingml/2006/main" xmlns:p="http://schemas.openxmlformats.org/presentationml/2006/main" xmlns:r="http://schemas.openxmlformats.org/officeDocument/2006/relationships">
   <p:cSld>
     <p:spTree>
@@ -5605,7 +9203,7 @@
                 </a:solidFill>
                 <a:latin typeface="Calibri"/>
               </a:rPr>
-              <a:t>WEEK 4  ·  FRIDAY  ·  FLIPKART, LUCKNOW  ·  FALLBACK</a:t>
+              <a:t>WEEK 4  ·  FRIDAY  ·  FORECASTING BASICS  ·  FALLBACK</a:t>
             </a:r>
           </a:p>
         </p:txBody>
@@ -5910,7 +9508,7 @@
                 </a:solidFill>
                 <a:latin typeface="Calibri"/>
               </a:rPr>
-              <a:t>Week 4 Day 5: how much is coming, and how wrong could we be</a:t>
+              <a:t>Week 4, Day 5. Forecasting basics: the fallback hour</a:t>
             </a:r>
           </a:p>
         </p:txBody>
@@ -5945,7 +9543,7 @@
                 </a:solidFill>
                 <a:latin typeface="Calibri"/>
               </a:rPr>
-              <a:t>S11  ·  11 / 14</a:t>
+              <a:t>S15  ·  15 / 18</a:t>
             </a:r>
           </a:p>
         </p:txBody>
@@ -5958,7 +9556,7 @@
 </p:sld>
 </file>
 
-<file path=ppt/slides/slide12.xml><?xml version="1.0" encoding="utf-8"?>
+<file path=ppt/slides/slide16.xml><?xml version="1.0" encoding="utf-8"?>
 <p:sld xmlns:a="http://schemas.openxmlformats.org/drawingml/2006/main" xmlns:p="http://schemas.openxmlformats.org/presentationml/2006/main" xmlns:r="http://schemas.openxmlformats.org/officeDocument/2006/relationships">
   <p:cSld>
     <p:spTree>
@@ -6116,7 +9714,7 @@
                 </a:solidFill>
                 <a:latin typeface="Calibri"/>
               </a:rPr>
-              <a:t>WEEK 4  ·  FRIDAY  ·  FLIPKART, LUCKNOW  ·  FALLBACK</a:t>
+              <a:t>WEEK 4  ·  FRIDAY  ·  FORECASTING BASICS  ·  FALLBACK</a:t>
             </a:r>
           </a:p>
         </p:txBody>
@@ -6452,7 +10050,7 @@
                 </a:solidFill>
                 <a:latin typeface="Calibri"/>
               </a:rPr>
-              <a:t>Week 4 Day 5: how much is coming, and how wrong could we be</a:t>
+              <a:t>Week 4, Day 5. Forecasting basics: the fallback hour</a:t>
             </a:r>
           </a:p>
         </p:txBody>
@@ -6487,7 +10085,7 @@
                 </a:solidFill>
                 <a:latin typeface="Calibri"/>
               </a:rPr>
-              <a:t>S12  ·  12 / 14</a:t>
+              <a:t>S16  ·  16 / 18</a:t>
             </a:r>
           </a:p>
         </p:txBody>
@@ -6500,7 +10098,7 @@
 </p:sld>
 </file>
 
-<file path=ppt/slides/slide13.xml><?xml version="1.0" encoding="utf-8"?>
+<file path=ppt/slides/slide17.xml><?xml version="1.0" encoding="utf-8"?>
 <p:sld xmlns:a="http://schemas.openxmlformats.org/drawingml/2006/main" xmlns:p="http://schemas.openxmlformats.org/presentationml/2006/main" xmlns:r="http://schemas.openxmlformats.org/officeDocument/2006/relationships">
   <p:cSld>
     <p:spTree>
@@ -6658,7 +10256,7 @@
                 </a:solidFill>
                 <a:latin typeface="Calibri"/>
               </a:rPr>
-              <a:t>WEEK 4  ·  FRIDAY  ·  FLIPKART, LUCKNOW  ·  FALLBACK</a:t>
+              <a:t>WEEK 4  ·  FRIDAY  ·  FORECASTING BASICS  ·  FALLBACK</a:t>
             </a:r>
           </a:p>
         </p:txBody>
@@ -6973,7 +10571,7 @@
                 </a:solidFill>
                 <a:latin typeface="Calibri"/>
               </a:rPr>
-              <a:t>Week 4 Day 5: how much is coming, and how wrong could we be</a:t>
+              <a:t>Week 4, Day 5. Forecasting basics: the fallback hour</a:t>
             </a:r>
           </a:p>
         </p:txBody>
@@ -7008,7 +10606,7 @@
                 </a:solidFill>
                 <a:latin typeface="Calibri"/>
               </a:rPr>
-              <a:t>S13  ·  13 / 14</a:t>
+              <a:t>S17  ·  17 / 18</a:t>
             </a:r>
           </a:p>
         </p:txBody>
@@ -7021,7 +10619,7 @@
 </p:sld>
 </file>
 
-<file path=ppt/slides/slide14.xml><?xml version="1.0" encoding="utf-8"?>
+<file path=ppt/slides/slide18.xml><?xml version="1.0" encoding="utf-8"?>
 <p:sld xmlns:a="http://schemas.openxmlformats.org/drawingml/2006/main" xmlns:p="http://schemas.openxmlformats.org/presentationml/2006/main" xmlns:r="http://schemas.openxmlformats.org/officeDocument/2006/relationships">
   <p:cSld>
     <p:spTree>
@@ -7179,7 +10777,7 @@
                 </a:solidFill>
                 <a:latin typeface="Calibri"/>
               </a:rPr>
-              <a:t>WEEK 4  ·  FRIDAY  ·  FLIPKART, LUCKNOW  ·  FALLBACK</a:t>
+              <a:t>WEEK 4  ·  FRIDAY  ·  FORECASTING BASICS  ·  FALLBACK</a:t>
             </a:r>
           </a:p>
         </p:txBody>
@@ -7476,7 +11074,7 @@
                 </a:solidFill>
                 <a:latin typeface="Calibri"/>
               </a:rPr>
-              <a:t>Hide at least as many weeks as the plan books, from one origin.</a:t>
+              <a:t>Hide at least as many weeks as the plan reaches ahead, from one origin.</a:t>
             </a:r>
           </a:p>
         </p:txBody>
@@ -7971,7 +11569,7 @@
                 </a:solidFill>
                 <a:latin typeface="Calibri"/>
               </a:rPr>
-              <a:t>Week 4 Day 5: how much is coming, and how wrong could we be</a:t>
+              <a:t>Week 4, Day 5. Forecasting basics: the fallback hour</a:t>
             </a:r>
           </a:p>
         </p:txBody>
@@ -8006,7 +11604,7 @@
                 </a:solidFill>
                 <a:latin typeface="Calibri"/>
               </a:rPr>
-              <a:t>S14  ·  14 / 14</a:t>
+              <a:t>S18  ·  18 / 18</a:t>
             </a:r>
           </a:p>
         </p:txBody>
@@ -8177,7 +11775,7 @@
                 </a:solidFill>
                 <a:latin typeface="Calibri"/>
               </a:rPr>
-              <a:t>WEEK 4  ·  FRIDAY  ·  FLIPKART, LUCKNOW  ·  FALLBACK</a:t>
+              <a:t>WEEK 4  ·  FRIDAY  ·  FORECASTING BASICS  ·  FALLBACK</a:t>
             </a:r>
           </a:p>
         </p:txBody>
@@ -8375,7 +11973,7 @@
                 </a:solidFill>
                 <a:latin typeface="Calibri"/>
               </a:rPr>
-              <a:t>Week 4 Day 5: how much is coming, and how wrong could we be</a:t>
+              <a:t>Week 4, Day 5. Forecasting basics: the fallback hour</a:t>
             </a:r>
           </a:p>
         </p:txBody>
@@ -8410,7 +12008,7 @@
                 </a:solidFill>
                 <a:latin typeface="Calibri"/>
               </a:rPr>
-              <a:t>S2  ·  2 / 14</a:t>
+              <a:t>S2  ·  2 / 18</a:t>
             </a:r>
           </a:p>
         </p:txBody>
@@ -8581,7 +12179,7 @@
                 </a:solidFill>
                 <a:latin typeface="Calibri"/>
               </a:rPr>
-              <a:t>WEEK 4  ·  FRIDAY  ·  FLIPKART, LUCKNOW  ·  FALLBACK</a:t>
+              <a:t>WEEK 4  ·  FRIDAY  ·  FORECASTING BASICS  ·  FALLBACK</a:t>
             </a:r>
           </a:p>
         </p:txBody>
@@ -9594,7 +13192,7 @@
                 </a:solidFill>
                 <a:latin typeface="Calibri"/>
               </a:rPr>
-              <a:t>Week 4 Day 5: how much is coming, and how wrong could we be</a:t>
+              <a:t>Week 4, Day 5. Forecasting basics: the fallback hour</a:t>
             </a:r>
           </a:p>
         </p:txBody>
@@ -9629,7 +13227,7 @@
                 </a:solidFill>
                 <a:latin typeface="Calibri"/>
               </a:rPr>
-              <a:t>S3  ·  3 / 14</a:t>
+              <a:t>S3  ·  3 / 18</a:t>
             </a:r>
           </a:p>
         </p:txBody>
@@ -9800,7 +13398,7 @@
                 </a:solidFill>
                 <a:latin typeface="Calibri"/>
               </a:rPr>
-              <a:t>WEEK 4  ·  FRIDAY  ·  FLIPKART, LUCKNOW  ·  FALLBACK</a:t>
+              <a:t>WEEK 4  ·  FRIDAY  ·  FORECASTING BASICS  ·  FALLBACK</a:t>
             </a:r>
           </a:p>
         </p:txBody>
@@ -10391,7 +13989,7 @@
                 </a:solidFill>
                 <a:latin typeface="Calibri"/>
               </a:rPr>
-              <a:t>Week 4 Day 5: how much is coming, and how wrong could we be</a:t>
+              <a:t>Week 4, Day 5. Forecasting basics: the fallback hour</a:t>
             </a:r>
           </a:p>
         </p:txBody>
@@ -10426,7 +14024,7 @@
                 </a:solidFill>
                 <a:latin typeface="Calibri"/>
               </a:rPr>
-              <a:t>S4  ·  4 / 14</a:t>
+              <a:t>S4  ·  4 / 18</a:t>
             </a:r>
           </a:p>
         </p:txBody>
@@ -10597,7 +14195,7 @@
                 </a:solidFill>
                 <a:latin typeface="Calibri"/>
               </a:rPr>
-              <a:t>WEEK 4  ·  FRIDAY  ·  FLIPKART, LUCKNOW  ·  FALLBACK</a:t>
+              <a:t>WEEK 4  ·  FRIDAY  ·  FORECASTING BASICS  ·  FALLBACK</a:t>
             </a:r>
           </a:p>
         </p:txBody>
@@ -10900,7 +14498,7 @@
                 </a:solidFill>
                 <a:latin typeface="Calibri"/>
               </a:rPr>
-              <a:t>The plan's last week is ten weeks past the data, so the test must reach ten weeks ahead; four cannot (FPP3, section 5.8, checked 12 October 2026).</a:t>
+              <a:t>The plan's last week is ten weeks past the data, so the test must reach ten weeks ahead; four cannot (FPP3, section 5.8, checked 13 October 2026).</a:t>
             </a:r>
           </a:p>
         </p:txBody>
@@ -11389,7 +14987,7 @@
                 </a:solidFill>
                 <a:latin typeface="Calibri"/>
               </a:rPr>
-              <a:t>Week 4 Day 5: how much is coming, and how wrong could we be</a:t>
+              <a:t>Week 4, Day 5. Forecasting basics: the fallback hour</a:t>
             </a:r>
           </a:p>
         </p:txBody>
@@ -11424,7 +15022,7 @@
                 </a:solidFill>
                 <a:latin typeface="Calibri"/>
               </a:rPr>
-              <a:t>S5  ·  5 / 14</a:t>
+              <a:t>S5  ·  5 / 18</a:t>
             </a:r>
           </a:p>
         </p:txBody>
@@ -11595,7 +15193,7 @@
                 </a:solidFill>
                 <a:latin typeface="Calibri"/>
               </a:rPr>
-              <a:t>WEEK 4  ·  FRIDAY  ·  FLIPKART, LUCKNOW  ·  FALLBACK</a:t>
+              <a:t>WEEK 4  ·  FRIDAY  ·  FORECASTING BASICS  ·  FALLBACK</a:t>
             </a:r>
           </a:p>
         </p:txBody>
@@ -11763,7 +15361,7 @@
                 </a:solidFill>
                 <a:latin typeface="Calibri"/>
               </a:rPr>
-              <a:t>Week 4 Day 5: how much is coming, and how wrong could we be</a:t>
+              <a:t>Week 4, Day 5. Forecasting basics: the fallback hour</a:t>
             </a:r>
           </a:p>
         </p:txBody>
@@ -11798,7 +15396,7 @@
                 </a:solidFill>
                 <a:latin typeface="Calibri"/>
               </a:rPr>
-              <a:t>S6  ·  6 / 14</a:t>
+              <a:t>S6  ·  6 / 18</a:t>
             </a:r>
           </a:p>
         </p:txBody>
@@ -11969,7 +15567,7 @@
                 </a:solidFill>
                 <a:latin typeface="Calibri"/>
               </a:rPr>
-              <a:t>WEEK 4  ·  FRIDAY  ·  FLIPKART, LUCKNOW  ·  FALLBACK</a:t>
+              <a:t>WEEK 4  ·  FRIDAY  ·  FORECASTING BASICS  ·  FALLBACK</a:t>
             </a:r>
           </a:p>
         </p:txBody>
@@ -12775,7 +16373,7 @@
                 </a:solidFill>
                 <a:latin typeface="Calibri"/>
               </a:rPr>
-              <a:t>Week 4 Day 5: how much is coming, and how wrong could we be</a:t>
+              <a:t>Week 4, Day 5. Forecasting basics: the fallback hour</a:t>
             </a:r>
           </a:p>
         </p:txBody>
@@ -12810,7 +16408,7 @@
                 </a:solidFill>
                 <a:latin typeface="Calibri"/>
               </a:rPr>
-              <a:t>S7  ·  7 / 14</a:t>
+              <a:t>S7  ·  7 / 18</a:t>
             </a:r>
           </a:p>
         </p:txBody>
@@ -12981,7 +16579,7 @@
                 </a:solidFill>
                 <a:latin typeface="Calibri"/>
               </a:rPr>
-              <a:t>WEEK 4  ·  FRIDAY  ·  FLIPKART, LUCKNOW  ·  FALLBACK</a:t>
+              <a:t>WEEK 4  ·  FRIDAY  ·  FORECASTING BASICS  ·  FALLBACK</a:t>
             </a:r>
           </a:p>
         </p:txBody>
@@ -13994,7 +17592,7 @@
                 </a:solidFill>
                 <a:latin typeface="Calibri"/>
               </a:rPr>
-              <a:t>Week 4 Day 5: how much is coming, and how wrong could we be</a:t>
+              <a:t>Week 4, Day 5. Forecasting basics: the fallback hour</a:t>
             </a:r>
           </a:p>
         </p:txBody>
@@ -14029,7 +17627,7 @@
                 </a:solidFill>
                 <a:latin typeface="Calibri"/>
               </a:rPr>
-              <a:t>S8  ·  8 / 14</a:t>
+              <a:t>S8  ·  8 / 18</a:t>
             </a:r>
           </a:p>
         </p:txBody>
@@ -14200,7 +17798,7 @@
                 </a:solidFill>
                 <a:latin typeface="Calibri"/>
               </a:rPr>
-              <a:t>WEEK 4  ·  FRIDAY  ·  FLIPKART, LUCKNOW  ·  FALLBACK</a:t>
+              <a:t>WEEK 4  ·  FRIDAY  ·  FORECASTING BASICS  ·  FALLBACK</a:t>
             </a:r>
           </a:p>
         </p:txBody>
@@ -14398,7 +17996,7 @@
                 </a:solidFill>
                 <a:latin typeface="Calibri"/>
               </a:rPr>
-              <a:t>Week 4 Day 5: how much is coming, and how wrong could we be</a:t>
+              <a:t>Week 4, Day 5. Forecasting basics: the fallback hour</a:t>
             </a:r>
           </a:p>
         </p:txBody>
@@ -14433,7 +18031,7 @@
                 </a:solidFill>
                 <a:latin typeface="Calibri"/>
               </a:rPr>
-              <a:t>S9  ·  9 / 14</a:t>
+              <a:t>S9  ·  9 / 18</a:t>
             </a:r>
           </a:p>
         </p:txBody>

</xml_diff>

<commit_message>
W04 D5: decks carry the leak-free festival record, the priced good-enough call and the error bar as typical miss and range
Half one dates every stall example as invented, labels each trap's check, moves chapter 3's prediction
before its reveal, prices MAPE's pull toward low forecasts and sets Diwali 2025's week at 296,900, 12,000
low with no growth. Half two shows the honest back-test, reads plus 22 and plus 4 against two windows,
prices a better forecast and runs the role-play in 4 minutes on S14. The fallback scores the rolling
origin with no growth. S54's notes name the hold-out animation; S16's notes mark the faculty session
tentative. Each .pptx is rebuilt from its markdown.

Co-Authored-By: Claude Opus 5.5 <noreply@anthropic.com>
Claude-Session: https://claude.ai/code/session_01Ey99XQtchbgeMsPeBDVB4c
</commit_message>
<xml_diff>
--- a/content/W04/D5/slides/C2_W04_D05_fallback_STUDENT.pptx
+++ b/content/W04/D5/slides/C2_W04_D05_fallback_STUDENT.pptx
@@ -1334,7 +1334,7 @@
           <a:lstStyle/>
           <a:p>
             <a:r>
-              <a:t>LIVE, 8 minutes. Groups run notebook 06 with the split moved to 24 August 2026, or read this table.</a:t>
+              <a:t>LIVE, 8 minutes. Groups run notebook 06 with the split moved to 24 August 2026, or read this chart.</a:t>
             </a:r>
           </a:p>
           <a:p>
@@ -1719,7 +1719,17 @@
           </a:p>
           <a:p>
             <a:r>
-              <a:t>2024's week at the same distance from Diwali, plus 4 percent. Transition: the vote.</a:t>
+              <a:t>2024's week at the same distance from Diwali and adds no growth, since in October 2025 no week had a</a:t>
+            </a:r>
+          </a:p>
+          <a:p>
+            <a:r>
+              <a:t>twin a year earlier outside the festival; every one of its misses is too low by about the year's</a:t>
+            </a:r>
+          </a:p>
+          <a:p>
+            <a:r>
+              <a:t>growth. Transition: the vote.</a:t>
             </a:r>
           </a:p>
         </p:txBody>
@@ -1859,12 +1869,12 @@
           <a:lstStyle/>
           <a:p>
             <a:r>
-              <a:t>LIVE, 8 minutes. 71,180 over 2,040 is about thirty-five: b was the closest option. Transition:</a:t>
-            </a:r>
-          </a:p>
-          <a:p>
-            <a:r>
-              <a:t>part 3, how far above the forecast the plan should sit.</a:t>
+              <a:t>LIVE, 8 minutes. 71,180 over 13,040 is about 5.5: b was the closest option. Transition: part 3, how</a:t>
+            </a:r>
+          </a:p>
+          <a:p>
+            <a:r>
+              <a:t>far above the forecast the plan should sit.</a:t>
             </a:r>
           </a:p>
         </p:txBody>
@@ -5151,7 +5161,7 @@
                 </a:solidFill>
                 <a:latin typeface="Calibri"/>
               </a:rPr>
-              <a:t>This hour runs only if the IITGN faculty session W4-4 (tentative) does not run. Illustrative case: the company is real, the situation and the data are synthetic, built for this class.</a:t>
+              <a:t>This session runs only if the IITGN faculty session W4-4 (tentative) does not run. Illustrative case: the company is real, the situation and the data are synthetic, built for this class.</a:t>
             </a:r>
           </a:p>
         </p:txBody>
@@ -5186,7 +5196,7 @@
                 </a:solidFill>
                 <a:latin typeface="Calibri"/>
               </a:rPr>
-              <a:t>Week 4, Day 5. Forecasting basics: the fallback hour</a:t>
+              <a:t>Week 4, Day 5. Forecasting basics: what does the fallback session test?</a:t>
             </a:r>
           </a:p>
         </p:txBody>
@@ -6409,7 +6419,7 @@
                 </a:solidFill>
                 <a:latin typeface="Calibri"/>
               </a:rPr>
-              <a:t>This part goes beyond the five subtopics of Friday's curriculum row: it is the plan quantile, the spine's addition, taught only in this hour and in notebook 07's depth section.</a:t>
+              <a:t>This part goes beyond the row, that is, beyond Friday's five topics: it is the plan quantile, taught only in this session and in notebook 07's depth section.</a:t>
             </a:r>
           </a:p>
         </p:txBody>
@@ -6444,7 +6454,7 @@
                 </a:solidFill>
                 <a:latin typeface="Calibri"/>
               </a:rPr>
-              <a:t>Week 4, Day 5. Forecasting basics: the fallback hour</a:t>
+              <a:t>Week 4, Day 5. Forecasting basics: what does the fallback session test?</a:t>
             </a:r>
           </a:p>
         </p:txBody>
@@ -6848,7 +6858,7 @@
                 </a:solidFill>
                 <a:latin typeface="Calibri"/>
               </a:rPr>
-              <a:t>Week 4, Day 5. Forecasting basics: the fallback hour</a:t>
+              <a:t>Week 4, Day 5. Forecasting basics: what does the fallback session test?</a:t>
             </a:r>
           </a:p>
         </p:txBody>
@@ -7252,7 +7262,7 @@
                 </a:solidFill>
                 <a:latin typeface="Calibri"/>
               </a:rPr>
-              <a:t>Week 4, Day 5. Forecasting basics: the fallback hour</a:t>
+              <a:t>Week 4, Day 5. Forecasting basics: what does the fallback session test?</a:t>
             </a:r>
           </a:p>
         </p:txBody>
@@ -8440,7 +8450,7 @@
                 </a:solidFill>
                 <a:latin typeface="Calibri"/>
               </a:rPr>
-              <a:t>Week 4, Day 5. Forecasting basics: the fallback hour</a:t>
+              <a:t>Week 4, Day 5. Forecasting basics: what does the fallback session test?</a:t>
             </a:r>
           </a:p>
         </p:txBody>
@@ -8997,7 +9007,7 @@
                 </a:solidFill>
                 <a:latin typeface="Calibri"/>
               </a:rPr>
-              <a:t>Week 4, Day 5. Forecasting basics: the fallback hour</a:t>
+              <a:t>Week 4, Day 5. Forecasting basics: what does the fallback session test?</a:t>
             </a:r>
           </a:p>
         </p:txBody>
@@ -9508,7 +9518,7 @@
                 </a:solidFill>
                 <a:latin typeface="Calibri"/>
               </a:rPr>
-              <a:t>Week 4, Day 5. Forecasting basics: the fallback hour</a:t>
+              <a:t>Week 4, Day 5. Forecasting basics: what does the fallback session test?</a:t>
             </a:r>
           </a:p>
         </p:txBody>
@@ -10050,7 +10060,7 @@
                 </a:solidFill>
                 <a:latin typeface="Calibri"/>
               </a:rPr>
-              <a:t>Week 4, Day 5. Forecasting basics: the fallback hour</a:t>
+              <a:t>Week 4, Day 5. Forecasting basics: what does the fallback session test?</a:t>
             </a:r>
           </a:p>
         </p:txBody>
@@ -10571,7 +10581,7 @@
                 </a:solidFill>
                 <a:latin typeface="Calibri"/>
               </a:rPr>
-              <a:t>Week 4, Day 5. Forecasting basics: the fallback hour</a:t>
+              <a:t>Week 4, Day 5. Forecasting basics: what does the fallback session test?</a:t>
             </a:r>
           </a:p>
         </p:txBody>
@@ -10847,7 +10857,7 @@
                 </a:solidFill>
                 <a:latin typeface="Calibri"/>
               </a:rPr>
-              <a:t>What survives this hour, whether or not the faculty session (tentative) runs?</a:t>
+              <a:t>What survives this session, whether or not the faculty session (tentative) runs?</a:t>
             </a:r>
           </a:p>
         </p:txBody>
@@ -11569,7 +11579,7 @@
                 </a:solidFill>
                 <a:latin typeface="Calibri"/>
               </a:rPr>
-              <a:t>Week 4, Day 5. Forecasting basics: the fallback hour</a:t>
+              <a:t>Week 4, Day 5. Forecasting basics: what does the fallback session test?</a:t>
             </a:r>
           </a:p>
         </p:txBody>
@@ -11938,7 +11948,7 @@
                 </a:solidFill>
                 <a:latin typeface="Calibri"/>
               </a:rPr>
-              <a:t>Festival-aligned and finance's rule still lead and the house bot stays next, while naive and drift fall below the vendor; every number moves a great deal. The four-week test rests on four misses and on one origin week.</a:t>
+              <a:t>Festival-aligned and finance's rule still lead and the house bot stays next, while naive and drift fall below the vendor: naive and drift move most, the copies of last year least. The four-week test rests on four misses and on one origin week.</a:t>
             </a:r>
           </a:p>
         </p:txBody>
@@ -11973,7 +11983,7 @@
                 </a:solidFill>
                 <a:latin typeface="Calibri"/>
               </a:rPr>
-              <a:t>Week 4, Day 5. Forecasting basics: the fallback hour</a:t>
+              <a:t>Week 4, Day 5. Forecasting basics: what does the fallback session test?</a:t>
             </a:r>
           </a:p>
         </p:txBody>
@@ -13192,7 +13202,7 @@
                 </a:solidFill>
                 <a:latin typeface="Calibri"/>
               </a:rPr>
-              <a:t>Week 4, Day 5. Forecasting basics: the fallback hour</a:t>
+              <a:t>Week 4, Day 5. Forecasting basics: what does the fallback session test?</a:t>
             </a:r>
           </a:p>
         </p:txBody>
@@ -13989,7 +13999,7 @@
                 </a:solidFill>
                 <a:latin typeface="Calibri"/>
               </a:rPr>
-              <a:t>Week 4, Day 5. Forecasting basics: the fallback hour</a:t>
+              <a:t>Week 4, Day 5. Forecasting basics: what does the fallback session test?</a:t>
             </a:r>
           </a:p>
         </p:txBody>
@@ -14265,7 +14275,7 @@
                 </a:solidFill>
                 <a:latin typeface="Calibri"/>
               </a:rPr>
-              <a:t>Why must the hidden weeks reach at least as far ahead as the plan does, ten weeks?</a:t>
+              <a:t>Why should the hidden weeks reach at least as far ahead as the plan does, ten weeks?</a:t>
             </a:r>
           </a:p>
         </p:txBody>
@@ -14279,7 +14289,7 @@
         <p:spPr>
           <a:xfrm>
             <a:off x="530352" y="1956816"/>
-            <a:ext cx="3588410" cy="2344420"/>
+            <a:ext cx="3588410" cy="2534412"/>
           </a:xfrm>
           <a:prstGeom prst="roundRect">
             <a:avLst>
@@ -14477,7 +14487,7 @@
         <p:spPr>
           <a:xfrm>
             <a:off x="731519" y="3303524"/>
-            <a:ext cx="3186074" cy="763016"/>
+            <a:ext cx="3186074" cy="944626"/>
           </a:xfrm>
           <a:prstGeom prst="rect">
             <a:avLst/>
@@ -14498,7 +14508,7 @@
                 </a:solidFill>
                 <a:latin typeface="Calibri"/>
               </a:rPr>
-              <a:t>The plan's last week is ten weeks past the data, so the test must reach ten weeks ahead; four cannot (FPP3, section 5.8, checked 13 October 2026).</a:t>
+              <a:t>The plan's last week is ten weeks past the data, so the test should ideally reach ten weeks ahead; four cannot (Forecasting: Principles and Practice, section 5.8, checked 13 October 2026).</a:t>
             </a:r>
           </a:p>
         </p:txBody>
@@ -14512,7 +14522,7 @@
         <p:spPr>
           <a:xfrm>
             <a:off x="4301642" y="1956816"/>
-            <a:ext cx="3588410" cy="2344420"/>
+            <a:ext cx="3588410" cy="2534412"/>
           </a:xfrm>
           <a:prstGeom prst="roundRect">
             <a:avLst>
@@ -14739,7 +14749,7 @@
         <p:spPr>
           <a:xfrm>
             <a:off x="8072932" y="1956816"/>
-            <a:ext cx="3588410" cy="2344420"/>
+            <a:ext cx="3588410" cy="2534412"/>
           </a:xfrm>
           <a:prstGeom prst="roundRect">
             <a:avLst>
@@ -14987,7 +14997,7 @@
                 </a:solidFill>
                 <a:latin typeface="Calibri"/>
               </a:rPr>
-              <a:t>Week 4, Day 5. Forecasting basics: the fallback hour</a:t>
+              <a:t>Week 4, Day 5. Forecasting basics: what does the fallback session test?</a:t>
             </a:r>
           </a:p>
         </p:txBody>
@@ -15361,7 +15371,7 @@
                 </a:solidFill>
                 <a:latin typeface="Calibri"/>
               </a:rPr>
-              <a:t>Week 4, Day 5. Forecasting basics: the fallback hour</a:t>
+              <a:t>Week 4, Day 5. Forecasting basics: what does the fallback session test?</a:t>
             </a:r>
           </a:p>
         </p:txBody>
@@ -15858,7 +15868,7 @@
                           </a:solidFill>
                           <a:latin typeface="Calibri"/>
                         </a:rPr>
-                        <a:t>417,040</a:t>
+                        <a:t>401,000</a:t>
                       </a:r>
                     </a:p>
                   </a:txBody>
@@ -15880,7 +15890,7 @@
                           </a:solidFill>
                           <a:latin typeface="Calibri"/>
                         </a:rPr>
-                        <a:t>1,160 too low</a:t>
+                        <a:t>17,200 too low</a:t>
                       </a:r>
                     </a:p>
                   </a:txBody>
@@ -15970,7 +15980,7 @@
                           </a:solidFill>
                           <a:latin typeface="Calibri"/>
                         </a:rPr>
-                        <a:t>370,448</a:t>
+                        <a:t>356,200</a:t>
                       </a:r>
                     </a:p>
                   </a:txBody>
@@ -15992,7 +16002,7 @@
                           </a:solidFill>
                           <a:latin typeface="Calibri"/>
                         </a:rPr>
-                        <a:t>1,448 too high</a:t>
+                        <a:t>12,800 too low</a:t>
                       </a:r>
                     </a:p>
                   </a:txBody>
@@ -16082,7 +16092,7 @@
                           </a:solidFill>
                           <a:latin typeface="Calibri"/>
                         </a:rPr>
-                        <a:t>308,776</a:t>
+                        <a:t>296,900</a:t>
                       </a:r>
                     </a:p>
                   </a:txBody>
@@ -16104,7 +16114,7 @@
                           </a:solidFill>
                           <a:latin typeface="Calibri"/>
                         </a:rPr>
-                        <a:t>124 too low</a:t>
+                        <a:t>12,000 too low</a:t>
                       </a:r>
                     </a:p>
                   </a:txBody>
@@ -16194,7 +16204,7 @@
                           </a:solidFill>
                           <a:latin typeface="Calibri"/>
                         </a:rPr>
-                        <a:t>187,824</a:t>
+                        <a:t>180,600</a:t>
                       </a:r>
                     </a:p>
                   </a:txBody>
@@ -16216,7 +16226,7 @@
                           </a:solidFill>
                           <a:latin typeface="Calibri"/>
                         </a:rPr>
-                        <a:t>776 too low</a:t>
+                        <a:t>8,000 too low</a:t>
                       </a:r>
                     </a:p>
                   </a:txBody>
@@ -16306,7 +16316,7 @@
                           </a:solidFill>
                           <a:latin typeface="Calibri"/>
                         </a:rPr>
-                        <a:t>221,208</a:t>
+                        <a:t>212,700</a:t>
                       </a:r>
                     </a:p>
                   </a:txBody>
@@ -16328,7 +16338,7 @@
                           </a:solidFill>
                           <a:latin typeface="Calibri"/>
                         </a:rPr>
-                        <a:t>6,692 too low</a:t>
+                        <a:t>15,200 too low</a:t>
                       </a:r>
                     </a:p>
                   </a:txBody>
@@ -16373,7 +16383,7 @@
                 </a:solidFill>
                 <a:latin typeface="Calibri"/>
               </a:rPr>
-              <a:t>Week 4, Day 5. Forecasting basics: the fallback hour</a:t>
+              <a:t>Week 4, Day 5. Forecasting basics: what does the fallback session test?</a:t>
             </a:r>
           </a:p>
         </p:txBody>
@@ -16820,7 +16830,7 @@
         <p:spPr>
           <a:xfrm>
             <a:off x="731519" y="2962656"/>
-            <a:ext cx="2243251" cy="498856"/>
+            <a:ext cx="2243251" cy="267716"/>
           </a:xfrm>
           <a:prstGeom prst="rect">
             <a:avLst/>
@@ -16841,7 +16851,7 @@
                 </a:solidFill>
                 <a:latin typeface="Calibri"/>
               </a:rPr>
-              <a:t>Naive, by about ten times</a:t>
+              <a:t>Naive, by about twice</a:t>
             </a:r>
           </a:p>
         </p:txBody>
@@ -16854,7 +16864,7 @@
         </p:nvSpPr>
         <p:spPr>
           <a:xfrm>
-            <a:off x="731519" y="3534664"/>
+            <a:off x="731519" y="3303524"/>
             <a:ext cx="2243251" cy="399796"/>
           </a:xfrm>
           <a:prstGeom prst="rect">
@@ -17068,7 +17078,7 @@
                 </a:solidFill>
                 <a:latin typeface="Calibri"/>
               </a:rPr>
-              <a:t>Naive, by about thirty-five times</a:t>
+              <a:t>Naive, by about five times</a:t>
             </a:r>
           </a:p>
         </p:txBody>
@@ -17330,7 +17340,7 @@
                 </a:solidFill>
                 <a:latin typeface="Calibri"/>
               </a:rPr>
-              <a:t>Copying 2024 adds 2024's own noise.</a:t>
+              <a:t>Copying 2024 adds 2024's own wobble.</a:t>
             </a:r>
           </a:p>
         </p:txBody>
@@ -17592,7 +17602,7 @@
                 </a:solidFill>
                 <a:latin typeface="Calibri"/>
               </a:rPr>
-              <a:t>Week 4, Day 5. Forecasting basics: the fallback hour</a:t>
+              <a:t>Week 4, Day 5. Forecasting basics: what does the fallback session test?</a:t>
             </a:r>
           </a:p>
         </p:txBody>
@@ -17833,7 +17843,7 @@
                 </a:solidFill>
                 <a:latin typeface="Georgia"/>
               </a:rPr>
-              <a:t>Answer: naive, by about thirty-five times</a:t>
+              <a:t>Answer: naive, by about five times</a:t>
             </a:r>
           </a:p>
         </p:txBody>
@@ -17961,7 +17971,7 @@
                 </a:solidFill>
                 <a:latin typeface="Calibri"/>
               </a:rPr>
-              <a:t>Naive's five misses average 71,180 a week and festival-aligned's 2,040. Near a festival the week before is a poor guide, because the weeks change sharply; last year's week at the same distance from Diwali is a good one.</a:t>
+              <a:t>Naive's five misses average 71,180 a week and festival-aligned's 13,040, with no growth added. Near a festival the week before is a poor guide, because the weeks change sharply; last year's week at the same distance from Diwali is a good one, low only by the growth nobody could yet measure.</a:t>
             </a:r>
           </a:p>
         </p:txBody>
@@ -17996,7 +18006,7 @@
                 </a:solidFill>
                 <a:latin typeface="Calibri"/>
               </a:rPr>
-              <a:t>Week 4, Day 5. Forecasting basics: the fallback hour</a:t>
+              <a:t>Week 4, Day 5. Forecasting basics: what does the fallback session test?</a:t>
             </a:r>
           </a:p>
         </p:txBody>

</xml_diff>